<commit_message>
docs: remove presentation speaker notes
</commit_message>
<xml_diff>
--- a/StrongRoom-Presentation.pptx
+++ b/StrongRoom-Presentation.pptx
@@ -2,27 +2,27 @@
 <file path=ppt/presentation.xml><?xml version="1.0" encoding="utf-8"?>
 <p:presentation xmlns:p="http://schemas.openxmlformats.org/presentationml/2006/main">
   <p:sldMasterIdLst>
-    <p:sldMasterId xmlns:r="http://schemas.openxmlformats.org/officeDocument/2006/relationships" id="2147483648" r:id="Rf97369e2ce9648e3"/>
+    <p:sldMasterId xmlns:r="http://schemas.openxmlformats.org/officeDocument/2006/relationships" id="2147483648" r:id="R474872d57807432d"/>
   </p:sldMasterIdLst>
   <p:notesMasterIdLst>
-    <p:notesMasterId xmlns:r="http://schemas.openxmlformats.org/officeDocument/2006/relationships" r:id="Rfcaaca84e81c4d05"/>
+    <p:notesMasterId xmlns:r="http://schemas.openxmlformats.org/officeDocument/2006/relationships" r:id="R04c5ffea6e504e81"/>
   </p:notesMasterIdLst>
   <p:sldIdLst>
-    <p:sldId xmlns:r="http://schemas.openxmlformats.org/officeDocument/2006/relationships" id="256" r:id="Rcaf0b722d54c4bcb"/>
-    <p:sldId xmlns:r="http://schemas.openxmlformats.org/officeDocument/2006/relationships" id="257" r:id="R0f4b9713613e4044"/>
-    <p:sldId xmlns:r="http://schemas.openxmlformats.org/officeDocument/2006/relationships" id="258" r:id="Rd9d50e3caad44119"/>
-    <p:sldId xmlns:r="http://schemas.openxmlformats.org/officeDocument/2006/relationships" id="259" r:id="Rcd754275dc5840b0"/>
-    <p:sldId xmlns:r="http://schemas.openxmlformats.org/officeDocument/2006/relationships" id="260" r:id="R4c2d1ac5ba8d4fcc"/>
-    <p:sldId xmlns:r="http://schemas.openxmlformats.org/officeDocument/2006/relationships" id="261" r:id="Rf8e79c07c5c94d34"/>
-    <p:sldId xmlns:r="http://schemas.openxmlformats.org/officeDocument/2006/relationships" id="262" r:id="R8f84da0f7dcd420d"/>
-    <p:sldId xmlns:r="http://schemas.openxmlformats.org/officeDocument/2006/relationships" id="263" r:id="R105c0a7f53124143"/>
-    <p:sldId xmlns:r="http://schemas.openxmlformats.org/officeDocument/2006/relationships" id="264" r:id="R03c38190b9d449fc"/>
-    <p:sldId xmlns:r="http://schemas.openxmlformats.org/officeDocument/2006/relationships" id="265" r:id="Rc9304a71ecec4e0b"/>
-    <p:sldId xmlns:r="http://schemas.openxmlformats.org/officeDocument/2006/relationships" id="266" r:id="R93ef586baabc429e"/>
-    <p:sldId xmlns:r="http://schemas.openxmlformats.org/officeDocument/2006/relationships" id="267" r:id="Rc23d4238d0ea4ab9"/>
-    <p:sldId xmlns:r="http://schemas.openxmlformats.org/officeDocument/2006/relationships" id="268" r:id="R61ae02431bce4ac4"/>
-    <p:sldId xmlns:r="http://schemas.openxmlformats.org/officeDocument/2006/relationships" id="269" r:id="R059910f7ce554c10"/>
-    <p:sldId xmlns:r="http://schemas.openxmlformats.org/officeDocument/2006/relationships" id="270" r:id="Re8c5e92907cf4450"/>
+    <p:sldId xmlns:r="http://schemas.openxmlformats.org/officeDocument/2006/relationships" id="256" r:id="R8ee54361a7e849fc"/>
+    <p:sldId xmlns:r="http://schemas.openxmlformats.org/officeDocument/2006/relationships" id="257" r:id="R541132f4fd214025"/>
+    <p:sldId xmlns:r="http://schemas.openxmlformats.org/officeDocument/2006/relationships" id="258" r:id="R6cff4975831645b6"/>
+    <p:sldId xmlns:r="http://schemas.openxmlformats.org/officeDocument/2006/relationships" id="259" r:id="R7449d43ecd8c4092"/>
+    <p:sldId xmlns:r="http://schemas.openxmlformats.org/officeDocument/2006/relationships" id="260" r:id="R1feb2de42f2742b2"/>
+    <p:sldId xmlns:r="http://schemas.openxmlformats.org/officeDocument/2006/relationships" id="261" r:id="R0a6b93e9cd1b4d3d"/>
+    <p:sldId xmlns:r="http://schemas.openxmlformats.org/officeDocument/2006/relationships" id="262" r:id="R58da356f809a4015"/>
+    <p:sldId xmlns:r="http://schemas.openxmlformats.org/officeDocument/2006/relationships" id="263" r:id="R80dbcc5a65d04f8a"/>
+    <p:sldId xmlns:r="http://schemas.openxmlformats.org/officeDocument/2006/relationships" id="264" r:id="R121900ed410543df"/>
+    <p:sldId xmlns:r="http://schemas.openxmlformats.org/officeDocument/2006/relationships" id="265" r:id="Rbf7b05d2c1734059"/>
+    <p:sldId xmlns:r="http://schemas.openxmlformats.org/officeDocument/2006/relationships" id="266" r:id="R48319b5c223447d2"/>
+    <p:sldId xmlns:r="http://schemas.openxmlformats.org/officeDocument/2006/relationships" id="267" r:id="R1f95247406844e43"/>
+    <p:sldId xmlns:r="http://schemas.openxmlformats.org/officeDocument/2006/relationships" id="268" r:id="R8dbab3eb7c204521"/>
+    <p:sldId xmlns:r="http://schemas.openxmlformats.org/officeDocument/2006/relationships" id="269" r:id="R3a74b04bcb1847d1"/>
+    <p:sldId xmlns:r="http://schemas.openxmlformats.org/officeDocument/2006/relationships" id="270" r:id="R980741ff0d4e4a55"/>
   </p:sldIdLst>
   <p:sldSz cx="12192000" cy="6858000"/>
   <p:notesSz cx="6858000" cy="9144000"/>
@@ -456,17 +456,7 @@
           <a:lstStyle xmlns:a="http://schemas.openxmlformats.org/drawingml/2006/main"/>
           <a:p xmlns:a="http://schemas.openxmlformats.org/drawingml/2006/main">
             <a:r>
-              <a:t>Hello everyone. Today I will explain StrongRoom by following one invoice from start to finish. I will use a simple example: a plumber repairs a pipe for a housing association and sends a bill for five hundred dollars. I will show how the invoice enters StrongRoom, how it is approved, how a payment is created, and where the payment can go. This is an illustrative example, not a real transaction.</a:t>
-            </a:r>
-          </a:p>
-          <a:p xmlns:a="http://schemas.openxmlformats.org/drawingml/2006/main">
-            <a:r>
               <a:t/>
-            </a:r>
-          </a:p>
-          <a:p xmlns:a="http://schemas.openxmlformats.org/drawingml/2006/main">
-            <a:r>
-              <a:t>Source: July 2026 StrongRoom KT recording and transcript. Confirm current configuration and operational procedures.</a:t>
             </a:r>
           </a:p>
         </p:txBody>
@@ -536,17 +526,7 @@
           <a:lstStyle xmlns:a="http://schemas.openxmlformats.org/drawingml/2006/main"/>
           <a:p xmlns:a="http://schemas.openxmlformats.org/drawingml/2006/main">
             <a:r>
-              <a:t>This slide focuses on one custom-check return flow shown in the recording. AvidPay creates CSV check files for the applicable payments and sends them to an incoming StrongRoom location. The service shown as PROD APN Integration watches that location, reads the files, and updates the related StrongRoom payment statuses. This is different from the XML handoff we discussed earlier. Other CSV files can serve other purposes, so the filename and service matter.</a:t>
-            </a:r>
-          </a:p>
-          <a:p xmlns:a="http://schemas.openxmlformats.org/drawingml/2006/main">
-            <a:r>
               <a:t/>
-            </a:r>
-          </a:p>
-          <a:p xmlns:a="http://schemas.openxmlformats.org/drawingml/2006/main">
-            <a:r>
-              <a:t>Source: July 2026 StrongRoom KT recording and transcript. Confirm current configuration and operational procedures.</a:t>
             </a:r>
           </a:p>
         </p:txBody>
@@ -616,17 +596,7 @@
           <a:lstStyle xmlns:a="http://schemas.openxmlformats.org/drawingml/2006/main"/>
           <a:p xmlns:a="http://schemas.openxmlformats.org/drawingml/2006/main">
             <a:r>
-              <a:t>Check batching means grouping eligible check payments so they can be prepared for a printer. For example, imagine payments for five hundred, three hundred, and two hundred dollars. StrongRoom collects the applicable payments into a check batch, prepares the required files, and transfers those files to the configured external printer. The exact file format and grouping can vary by route and printer.</a:t>
-            </a:r>
-          </a:p>
-          <a:p xmlns:a="http://schemas.openxmlformats.org/drawingml/2006/main">
-            <a:r>
               <a:t/>
-            </a:r>
-          </a:p>
-          <a:p xmlns:a="http://schemas.openxmlformats.org/drawingml/2006/main">
-            <a:r>
-              <a:t>Source: July 2026 StrongRoom KT recording and transcript. Confirm current configuration and operational procedures.</a:t>
             </a:r>
           </a:p>
         </p:txBody>
@@ -696,17 +666,7 @@
           <a:lstStyle xmlns:a="http://schemas.openxmlformats.org/drawingml/2006/main"/>
           <a:p xmlns:a="http://schemas.openxmlformats.org/drawingml/2006/main">
             <a:r>
-              <a:t>These milestones should be checked separately. First, was the batch created? Second, were the files transferred? Third, did the printer receive them? Finally, were the checks processed or printed? A successful file transfer by itself does not prove that every check printed. For an incident, we should check the applicable printer acknowledgement and any reported exceptions before deciding where the process stopped.</a:t>
-            </a:r>
-          </a:p>
-          <a:p xmlns:a="http://schemas.openxmlformats.org/drawingml/2006/main">
-            <a:r>
               <a:t/>
-            </a:r>
-          </a:p>
-          <a:p xmlns:a="http://schemas.openxmlformats.org/drawingml/2006/main">
-            <a:r>
-              <a:t>Source: July 2026 StrongRoom KT recording and transcript. Confirm current configuration and operational procedures.</a:t>
             </a:r>
           </a:p>
         </p:txBody>
@@ -776,17 +736,7 @@
           <a:lstStyle xmlns:a="http://schemas.openxmlformats.org/drawingml/2006/main"/>
           <a:p xmlns:a="http://schemas.openxmlformats.org/drawingml/2006/main">
             <a:r>
-              <a:t>The accounting integration is a separate handoff. StrongRoom can exchange supported information, such as invoices, payments, or images, with the customer’s accounting system. A payment or check may progress while an accounting update needs attention. So if the customer cannot see information in the accounting system, we should investigate that integration separately and check the current client configuration.</a:t>
-            </a:r>
-          </a:p>
-          <a:p xmlns:a="http://schemas.openxmlformats.org/drawingml/2006/main">
-            <a:r>
               <a:t/>
-            </a:r>
-          </a:p>
-          <a:p xmlns:a="http://schemas.openxmlformats.org/drawingml/2006/main">
-            <a:r>
-              <a:t>Source: July 2026 StrongRoom KT recording and transcript. Confirm current configuration and operational procedures.</a:t>
             </a:r>
           </a:p>
         </p:txBody>
@@ -856,17 +806,7 @@
           <a:lstStyle xmlns:a="http://schemas.openxmlformats.org/drawingml/2006/main"/>
           <a:p xmlns:a="http://schemas.openxmlformats.org/drawingml/2006/main">
             <a:r>
-              <a:t>From an SRE perspective, I would trace one invoice or payment through each boundary. I would establish whether it arrived, whether it was indexed and approved, whether a payment was generated, which route applied, whether a batch and its files were sent, and what the external system reported. I would find the last confirmed successful step and investigate the next handoff. A background service showing as running is not, by itself, proof that it is processing work.</a:t>
-            </a:r>
-          </a:p>
-          <a:p xmlns:a="http://schemas.openxmlformats.org/drawingml/2006/main">
-            <a:r>
               <a:t/>
-            </a:r>
-          </a:p>
-          <a:p xmlns:a="http://schemas.openxmlformats.org/drawingml/2006/main">
-            <a:r>
-              <a:t>Source: July 2026 StrongRoom KT recording and transcript. Confirm current configuration and operational procedures.</a:t>
             </a:r>
           </a:p>
         </p:txBody>
@@ -936,17 +876,7 @@
           <a:lstStyle xmlns:a="http://schemas.openxmlformats.org/drawingml/2006/main"/>
           <a:p xmlns:a="http://schemas.openxmlformats.org/drawingml/2006/main">
             <a:r>
-              <a:t>To summarize, StrongRoom receives invoice information, an internal team checks it, and the buyer approves it. A scheduled process creates payment records for eligible invoices. The configured route determines whether an applicable custom check stays on the StrongRoom path or a payment goes to AvidPay. Applicable checks are batched for an external printer. Accounting integration and payment status are separate checkpoints. That completes the end-to-end walkthrough. I am happy to take questions.</a:t>
-            </a:r>
-          </a:p>
-          <a:p xmlns:a="http://schemas.openxmlformats.org/drawingml/2006/main">
-            <a:r>
               <a:t/>
-            </a:r>
-          </a:p>
-          <a:p xmlns:a="http://schemas.openxmlformats.org/drawingml/2006/main">
-            <a:r>
-              <a:t>Source: July 2026 StrongRoom KT recording and transcript. Confirm current configuration and operational procedures.</a:t>
             </a:r>
           </a:p>
         </p:txBody>
@@ -1016,17 +946,7 @@
           <a:lstStyle xmlns:a="http://schemas.openxmlformats.org/drawingml/2006/main"/>
           <a:p xmlns:a="http://schemas.openxmlformats.org/drawingml/2006/main">
             <a:r>
-              <a:t>First, what is an invoice? An invoice is a bill sent by a supplier to a customer. In our example, ABC Plumbing is the supplier, and Sunrise Housing Association is the buyer. The invoice says that Sunrise owes ABC Plumbing five hundred dollars for the pipe repair. At this point it is a request for payment. It does not mean that money has already been paid.</a:t>
-            </a:r>
-          </a:p>
-          <a:p xmlns:a="http://schemas.openxmlformats.org/drawingml/2006/main">
-            <a:r>
               <a:t/>
-            </a:r>
-          </a:p>
-          <a:p xmlns:a="http://schemas.openxmlformats.org/drawingml/2006/main">
-            <a:r>
-              <a:t>Source: July 2026 StrongRoom KT recording and transcript. Confirm current configuration and operational procedures.</a:t>
             </a:r>
           </a:p>
         </p:txBody>
@@ -1096,17 +1016,7 @@
           <a:lstStyle xmlns:a="http://schemas.openxmlformats.org/drawingml/2006/main"/>
           <a:p xmlns:a="http://schemas.openxmlformats.org/drawingml/2006/main">
             <a:r>
-              <a:t>Now let us see how the invoice enters StrongRoom. In the email route described in the session, the supplier sends the invoice to the buyer’s inbox hosted on Rackspace. A background service called an invoice worker checks the inbox, picks up the message, and processes it so that the invoice information enters StrongRoom. The session also described invoices arriving as scanned documents. Receiving the email and creating the invoice record are separate steps.</a:t>
-            </a:r>
-          </a:p>
-          <a:p xmlns:a="http://schemas.openxmlformats.org/drawingml/2006/main">
-            <a:r>
               <a:t/>
-            </a:r>
-          </a:p>
-          <a:p xmlns:a="http://schemas.openxmlformats.org/drawingml/2006/main">
-            <a:r>
-              <a:t>Source: July 2026 StrongRoom KT recording and transcript. Confirm current configuration and operational procedures.</a:t>
             </a:r>
           </a:p>
         </p:txBody>
@@ -1176,17 +1086,7 @@
           <a:lstStyle xmlns:a="http://schemas.openxmlformats.org/drawingml/2006/main"/>
           <a:p xmlns:a="http://schemas.openxmlformats.org/drawingml/2006/main">
             <a:r>
-              <a:t>Once the invoice is in StrongRoom, an internal team checks and enters the required information. This step is called indexing. After indexing, the invoice goes to the buyer’s association for review. Association members approve it if the details are acceptable. After final approval, the invoice is authorized for payment. That makes it eligible for the next process, but it does not mean the supplier has been paid.</a:t>
-            </a:r>
-          </a:p>
-          <a:p xmlns:a="http://schemas.openxmlformats.org/drawingml/2006/main">
-            <a:r>
               <a:t/>
-            </a:r>
-          </a:p>
-          <a:p xmlns:a="http://schemas.openxmlformats.org/drawingml/2006/main">
-            <a:r>
-              <a:t>Source: July 2026 StrongRoom KT recording and transcript. Confirm current configuration and operational procedures.</a:t>
             </a:r>
           </a:p>
         </p:txBody>
@@ -1256,17 +1156,7 @@
           <a:lstStyle xmlns:a="http://schemas.openxmlformats.org/drawingml/2006/main"/>
           <a:p xmlns:a="http://schemas.openxmlformats.org/drawingml/2006/main">
             <a:r>
-              <a:t>Next, a scheduled payment-generation process looks for eligible invoices and creates payment records in StrongRoom. For our example, the approved five-hundred-dollar invoice becomes associated with a payment to ABC Plumbing. The invoice is the bill. The payment record represents the payment that needs to be processed. Creating the payment is a milestone, but the payment still has to follow its route.</a:t>
-            </a:r>
-          </a:p>
-          <a:p xmlns:a="http://schemas.openxmlformats.org/drawingml/2006/main">
-            <a:r>
               <a:t/>
-            </a:r>
-          </a:p>
-          <a:p xmlns:a="http://schemas.openxmlformats.org/drawingml/2006/main">
-            <a:r>
-              <a:t>Source: July 2026 StrongRoom KT recording and transcript. Confirm current configuration and operational procedures.</a:t>
             </a:r>
           </a:p>
         </p:txBody>
@@ -1336,17 +1226,7 @@
           <a:lstStyle xmlns:a="http://schemas.openxmlformats.org/drawingml/2006/main"/>
           <a:p xmlns:a="http://schemas.openxmlformats.org/drawingml/2006/main">
             <a:r>
-              <a:t>After the payment record is created, the next question is which route applies. In this walkthrough, I will show a StrongRoom check-system route and an AvidPay route. The applicable route depends on the buyer’s configuration and the payment type. A buyer can have more than one configured payment system, so we need to look at the particular payment rather than assume the whole buyer always uses one route.</a:t>
-            </a:r>
-          </a:p>
-          <a:p xmlns:a="http://schemas.openxmlformats.org/drawingml/2006/main">
-            <a:r>
               <a:t/>
-            </a:r>
-          </a:p>
-          <a:p xmlns:a="http://schemas.openxmlformats.org/drawingml/2006/main">
-            <a:r>
-              <a:t>Source: July 2026 StrongRoom KT recording and transcript. Confirm current configuration and operational procedures.</a:t>
             </a:r>
           </a:p>
         </p:txBody>
@@ -1416,17 +1296,7 @@
           <a:lstStyle xmlns:a="http://schemas.openxmlformats.org/drawingml/2006/main"/>
           <a:p xmlns:a="http://schemas.openxmlformats.org/drawingml/2006/main">
             <a:r>
-              <a:t>First, let us take an applicable StrongRoom custom-check route. Here the payment stays on the StrongRoom side and does not need an AvidPay round trip. A later check-batching process picks up eligible payments. StrongRoom prepares the required check files and sends them to the configured external printer. The external provider processes and prints the checks. StrongRoom itself is the application coordinating the handoff.</a:t>
-            </a:r>
-          </a:p>
-          <a:p xmlns:a="http://schemas.openxmlformats.org/drawingml/2006/main">
-            <a:r>
               <a:t/>
-            </a:r>
-          </a:p>
-          <a:p xmlns:a="http://schemas.openxmlformats.org/drawingml/2006/main">
-            <a:r>
-              <a:t>Source: July 2026 StrongRoom KT recording and transcript. Confirm current configuration and operational procedures.</a:t>
             </a:r>
           </a:p>
         </p:txBody>
@@ -1496,17 +1366,7 @@
           <a:lstStyle xmlns:a="http://schemas.openxmlformats.org/drawingml/2006/main"/>
           <a:p xmlns:a="http://schemas.openxmlformats.org/drawingml/2006/main">
             <a:r>
-              <a:t>Now let us take the AvidPay route. A separate StrongRoom batching process collects eligible payments. In the flow shown in the session, it creates an XML file for a client with the relevant payment information and sends it to AvidPay. AvidPay then creates a corresponding payment record. This gives us a handoff to trace: the StrongRoom payment, the outbound file, and the corresponding AvidPay payment.</a:t>
-            </a:r>
-          </a:p>
-          <a:p xmlns:a="http://schemas.openxmlformats.org/drawingml/2006/main">
-            <a:r>
               <a:t/>
-            </a:r>
-          </a:p>
-          <a:p xmlns:a="http://schemas.openxmlformats.org/drawingml/2006/main">
-            <a:r>
-              <a:t>Source: July 2026 StrongRoom KT recording and transcript. Confirm current configuration and operational procedures.</a:t>
             </a:r>
           </a:p>
         </p:txBody>
@@ -1576,17 +1436,7 @@
           <a:lstStyle xmlns:a="http://schemas.openxmlformats.org/drawingml/2006/main"/>
           <a:p xmlns:a="http://schemas.openxmlformats.org/drawingml/2006/main">
             <a:r>
-              <a:t>After a payment reaches AvidPay, what happens next depends on its payment type and configuration. An ACH payment follows an applicable electronic bank-payment path. A virtual card follows a card-payment path. Checks follow the configured check path. Some custom checks are redirected back to StrongRoom. Other custom checks can follow a different printer route, and not every payment sent to AvidPay comes back.</a:t>
-            </a:r>
-          </a:p>
-          <a:p xmlns:a="http://schemas.openxmlformats.org/drawingml/2006/main">
-            <a:r>
               <a:t/>
-            </a:r>
-          </a:p>
-          <a:p xmlns:a="http://schemas.openxmlformats.org/drawingml/2006/main">
-            <a:r>
-              <a:t>Source: July 2026 StrongRoom KT recording and transcript. Confirm current configuration and operational procedures.</a:t>
             </a:r>
           </a:p>
         </p:txBody>
@@ -4029,12 +3879,12 @@
   </p:cSld>
   <p:clrMap bg1="lt1" tx1="dk1" bg2="lt2" tx2="dk2" accent1="accent1" accent2="accent2" accent3="accent3" accent4="accent4" accent5="accent5" accent6="accent6" hlink="hlink" folHlink="folHlink"/>
   <p:sldLayoutIdLst>
-    <p:sldLayoutId xmlns:r="http://schemas.openxmlformats.org/officeDocument/2006/relationships" id="2147483649" r:id="Re6d301a86d5c4fe1"/>
-    <p:sldLayoutId xmlns:r="http://schemas.openxmlformats.org/officeDocument/2006/relationships" id="2147483650" r:id="R7e6102e9bede4825"/>
-    <p:sldLayoutId xmlns:r="http://schemas.openxmlformats.org/officeDocument/2006/relationships" id="2147483651" r:id="R705811bed5434f58"/>
-    <p:sldLayoutId xmlns:r="http://schemas.openxmlformats.org/officeDocument/2006/relationships" id="2147483652" r:id="R195afc46b0774848"/>
-    <p:sldLayoutId xmlns:r="http://schemas.openxmlformats.org/officeDocument/2006/relationships" id="2147483653" r:id="R5d30328ed3884e15"/>
-    <p:sldLayoutId xmlns:r="http://schemas.openxmlformats.org/officeDocument/2006/relationships" id="2147483654" r:id="Rddb7138e10ec4252"/>
+    <p:sldLayoutId xmlns:r="http://schemas.openxmlformats.org/officeDocument/2006/relationships" id="2147483649" r:id="Rd4f513f29b8849ed"/>
+    <p:sldLayoutId xmlns:r="http://schemas.openxmlformats.org/officeDocument/2006/relationships" id="2147483650" r:id="R54b59061612248c5"/>
+    <p:sldLayoutId xmlns:r="http://schemas.openxmlformats.org/officeDocument/2006/relationships" id="2147483651" r:id="R7d40621e9c194f12"/>
+    <p:sldLayoutId xmlns:r="http://schemas.openxmlformats.org/officeDocument/2006/relationships" id="2147483652" r:id="Rd3d15250dc6c44bb"/>
+    <p:sldLayoutId xmlns:r="http://schemas.openxmlformats.org/officeDocument/2006/relationships" id="2147483653" r:id="R06fa424e94b74c23"/>
+    <p:sldLayoutId xmlns:r="http://schemas.openxmlformats.org/officeDocument/2006/relationships" id="2147483654" r:id="R5f46f17475bc44a3"/>
   </p:sldLayoutIdLst>
   <p:txStyles>
     <p:titleStyle>
@@ -4585,7 +4435,7 @@
           <p:cNvPr id="18" name="">
             <a:extLst xmlns:a="http://schemas.openxmlformats.org/drawingml/2006/main">
               <a:ext uri="{FF2B5EF4-FFF2-40B4-BE49-F238E27FC236}">
-                <a16:creationId xmlns:a16="http://schemas.microsoft.com/office/drawing/2014/main" id="{CE0545B6-F54E-4DA2-92D5-3D4BEE814F05}"/>
+                <a16:creationId xmlns:a16="http://schemas.microsoft.com/office/drawing/2014/main" id="{AA94C97B-190B-40AA-8C6F-C6067D53E433}"/>
               </a:ext>
             </a:extLst>
           </p:cNvPr>
@@ -4617,7 +4467,7 @@
           <p:cNvPr id="17" name="">
             <a:extLst xmlns:a="http://schemas.openxmlformats.org/drawingml/2006/main">
               <a:ext uri="{FF2B5EF4-FFF2-40B4-BE49-F238E27FC236}">
-                <a16:creationId xmlns:a16="http://schemas.microsoft.com/office/drawing/2014/main" id="{74B37286-D78C-4B82-A15C-AD5885E1AA1D}"/>
+                <a16:creationId xmlns:a16="http://schemas.microsoft.com/office/drawing/2014/main" id="{67C19A15-042D-4424-9FBC-46C3B6CCF8DC}"/>
               </a:ext>
             </a:extLst>
           </p:cNvPr>
@@ -4649,7 +4499,7 @@
           <p:cNvPr id="16" name="">
             <a:extLst xmlns:a="http://schemas.openxmlformats.org/drawingml/2006/main">
               <a:ext uri="{FF2B5EF4-FFF2-40B4-BE49-F238E27FC236}">
-                <a16:creationId xmlns:a16="http://schemas.microsoft.com/office/drawing/2014/main" id="{F8F63FD6-1442-43A9-96A9-B113100CB479}"/>
+                <a16:creationId xmlns:a16="http://schemas.microsoft.com/office/drawing/2014/main" id="{9918491E-0B99-445F-8ED5-2581B3CE4CFC}"/>
               </a:ext>
             </a:extLst>
           </p:cNvPr>
@@ -7194,7 +7044,7 @@
           <p:cNvPr id="18" name="">
             <a:extLst xmlns:a="http://schemas.openxmlformats.org/drawingml/2006/main">
               <a:ext uri="{FF2B5EF4-FFF2-40B4-BE49-F238E27FC236}">
-                <a16:creationId xmlns:a16="http://schemas.microsoft.com/office/drawing/2014/main" id="{4291C607-9D76-4C0A-B6E2-0C347B2FBD77}"/>
+                <a16:creationId xmlns:a16="http://schemas.microsoft.com/office/drawing/2014/main" id="{E2306F20-2282-4B08-BBA4-BFFEF528D2B5}"/>
               </a:ext>
             </a:extLst>
           </p:cNvPr>
@@ -7226,7 +7076,7 @@
           <p:cNvPr id="17" name="">
             <a:extLst xmlns:a="http://schemas.openxmlformats.org/drawingml/2006/main">
               <a:ext uri="{FF2B5EF4-FFF2-40B4-BE49-F238E27FC236}">
-                <a16:creationId xmlns:a16="http://schemas.microsoft.com/office/drawing/2014/main" id="{4743600B-75C5-4642-AD40-C85BBC5946A3}"/>
+                <a16:creationId xmlns:a16="http://schemas.microsoft.com/office/drawing/2014/main" id="{62756074-D649-41BE-8F78-867A37D912CC}"/>
               </a:ext>
             </a:extLst>
           </p:cNvPr>
@@ -7258,7 +7108,7 @@
           <p:cNvPr id="16" name="">
             <a:extLst xmlns:a="http://schemas.openxmlformats.org/drawingml/2006/main">
               <a:ext uri="{FF2B5EF4-FFF2-40B4-BE49-F238E27FC236}">
-                <a16:creationId xmlns:a16="http://schemas.microsoft.com/office/drawing/2014/main" id="{78FFC9A9-5F08-40CE-9A67-94BA32D393D5}"/>
+                <a16:creationId xmlns:a16="http://schemas.microsoft.com/office/drawing/2014/main" id="{C2F747FA-FF54-4865-97C4-38B539DA2C32}"/>
               </a:ext>
             </a:extLst>
           </p:cNvPr>
@@ -9814,7 +9664,7 @@
           <p:cNvPr id="18" name="">
             <a:extLst xmlns:a="http://schemas.openxmlformats.org/drawingml/2006/main">
               <a:ext uri="{FF2B5EF4-FFF2-40B4-BE49-F238E27FC236}">
-                <a16:creationId xmlns:a16="http://schemas.microsoft.com/office/drawing/2014/main" id="{266D5FB2-5A61-4F7F-B83B-E676FE770746}"/>
+                <a16:creationId xmlns:a16="http://schemas.microsoft.com/office/drawing/2014/main" id="{4F7F6DDE-0A69-4C2A-A57C-6A76B0AAF8C5}"/>
               </a:ext>
             </a:extLst>
           </p:cNvPr>
@@ -9848,7 +9698,7 @@
           <p:cNvPr id="14" name="">
             <a:extLst xmlns:a="http://schemas.openxmlformats.org/drawingml/2006/main">
               <a:ext uri="{FF2B5EF4-FFF2-40B4-BE49-F238E27FC236}">
-                <a16:creationId xmlns:a16="http://schemas.microsoft.com/office/drawing/2014/main" id="{8700D335-BEBE-4428-9D61-6D887F9AD417}"/>
+                <a16:creationId xmlns:a16="http://schemas.microsoft.com/office/drawing/2014/main" id="{62F9ADE9-D096-4307-A88A-924FE404647A}"/>
               </a:ext>
             </a:extLst>
           </p:cNvPr>
@@ -9880,7 +9730,7 @@
           <p:cNvPr id="10" name="">
             <a:extLst xmlns:a="http://schemas.openxmlformats.org/drawingml/2006/main">
               <a:ext uri="{FF2B5EF4-FFF2-40B4-BE49-F238E27FC236}">
-                <a16:creationId xmlns:a16="http://schemas.microsoft.com/office/drawing/2014/main" id="{A6644C48-EB39-4EF2-81C4-728A4017AB83}"/>
+                <a16:creationId xmlns:a16="http://schemas.microsoft.com/office/drawing/2014/main" id="{0CCB6B4C-C2E5-4D9A-BC95-382758C996D4}"/>
               </a:ext>
             </a:extLst>
           </p:cNvPr>
@@ -12269,7 +12119,7 @@
           <p:cNvPr id="18" name="">
             <a:extLst xmlns:a="http://schemas.openxmlformats.org/drawingml/2006/main">
               <a:ext uri="{FF2B5EF4-FFF2-40B4-BE49-F238E27FC236}">
-                <a16:creationId xmlns:a16="http://schemas.microsoft.com/office/drawing/2014/main" id="{99B4DF24-6914-4BE6-8EA6-B6C7A42EC142}"/>
+                <a16:creationId xmlns:a16="http://schemas.microsoft.com/office/drawing/2014/main" id="{D4EC505B-9139-4BB2-B3CD-1EC48D5314F8}"/>
               </a:ext>
             </a:extLst>
           </p:cNvPr>
@@ -12301,7 +12151,7 @@
           <p:cNvPr id="17" name="">
             <a:extLst xmlns:a="http://schemas.openxmlformats.org/drawingml/2006/main">
               <a:ext uri="{FF2B5EF4-FFF2-40B4-BE49-F238E27FC236}">
-                <a16:creationId xmlns:a16="http://schemas.microsoft.com/office/drawing/2014/main" id="{F550F408-5916-4102-8DC0-E5983454FF4A}"/>
+                <a16:creationId xmlns:a16="http://schemas.microsoft.com/office/drawing/2014/main" id="{69D1A3FA-C1D5-461E-A599-7362796F2857}"/>
               </a:ext>
             </a:extLst>
           </p:cNvPr>
@@ -12333,7 +12183,7 @@
           <p:cNvPr id="16" name="">
             <a:extLst xmlns:a="http://schemas.openxmlformats.org/drawingml/2006/main">
               <a:ext uri="{FF2B5EF4-FFF2-40B4-BE49-F238E27FC236}">
-                <a16:creationId xmlns:a16="http://schemas.microsoft.com/office/drawing/2014/main" id="{A2C43535-618A-4335-9A0C-E57D6A52E919}"/>
+                <a16:creationId xmlns:a16="http://schemas.microsoft.com/office/drawing/2014/main" id="{11F016D3-C6B1-4D43-B771-89E8F638E635}"/>
               </a:ext>
             </a:extLst>
           </p:cNvPr>
@@ -14889,7 +14739,7 @@
           <p:cNvPr id="14" name="">
             <a:extLst xmlns:a="http://schemas.openxmlformats.org/drawingml/2006/main">
               <a:ext uri="{FF2B5EF4-FFF2-40B4-BE49-F238E27FC236}">
-                <a16:creationId xmlns:a16="http://schemas.microsoft.com/office/drawing/2014/main" id="{F5CA0B17-C32C-4AF5-9521-D7116106A345}"/>
+                <a16:creationId xmlns:a16="http://schemas.microsoft.com/office/drawing/2014/main" id="{D968CF8C-CE2C-4BD4-9A44-AF1D26F61024}"/>
               </a:ext>
             </a:extLst>
           </p:cNvPr>
@@ -14921,7 +14771,7 @@
           <p:cNvPr id="13" name="">
             <a:extLst xmlns:a="http://schemas.openxmlformats.org/drawingml/2006/main">
               <a:ext uri="{FF2B5EF4-FFF2-40B4-BE49-F238E27FC236}">
-                <a16:creationId xmlns:a16="http://schemas.microsoft.com/office/drawing/2014/main" id="{406EC33A-1068-49AA-AADC-463C2BFB5235}"/>
+                <a16:creationId xmlns:a16="http://schemas.microsoft.com/office/drawing/2014/main" id="{E8B3C032-8CDD-494B-9B6C-98822CE0B121}"/>
               </a:ext>
             </a:extLst>
           </p:cNvPr>
@@ -16935,7 +16785,7 @@
           <p:cNvPr id="22" name="">
             <a:extLst xmlns:a="http://schemas.openxmlformats.org/drawingml/2006/main">
               <a:ext uri="{FF2B5EF4-FFF2-40B4-BE49-F238E27FC236}">
-                <a16:creationId xmlns:a16="http://schemas.microsoft.com/office/drawing/2014/main" id="{E62B6BB5-6256-4E4E-89E1-E7BD80CC7333}"/>
+                <a16:creationId xmlns:a16="http://schemas.microsoft.com/office/drawing/2014/main" id="{A41FFF4F-B728-451C-A3EA-723248546C72}"/>
               </a:ext>
             </a:extLst>
           </p:cNvPr>
@@ -16967,7 +16817,7 @@
           <p:cNvPr id="21" name="">
             <a:extLst xmlns:a="http://schemas.openxmlformats.org/drawingml/2006/main">
               <a:ext uri="{FF2B5EF4-FFF2-40B4-BE49-F238E27FC236}">
-                <a16:creationId xmlns:a16="http://schemas.microsoft.com/office/drawing/2014/main" id="{54BC39A7-6331-46C3-966B-AF8D32A0144F}"/>
+                <a16:creationId xmlns:a16="http://schemas.microsoft.com/office/drawing/2014/main" id="{A007DD69-A859-499E-9E94-00F9F49F6EEA}"/>
               </a:ext>
             </a:extLst>
           </p:cNvPr>
@@ -16999,7 +16849,7 @@
           <p:cNvPr id="20" name="">
             <a:extLst xmlns:a="http://schemas.openxmlformats.org/drawingml/2006/main">
               <a:ext uri="{FF2B5EF4-FFF2-40B4-BE49-F238E27FC236}">
-                <a16:creationId xmlns:a16="http://schemas.microsoft.com/office/drawing/2014/main" id="{54BCAE9F-AA5E-4637-AD87-F4C4ACD384DD}"/>
+                <a16:creationId xmlns:a16="http://schemas.microsoft.com/office/drawing/2014/main" id="{BE48E7CC-4B77-4699-ADC9-6DDC3C3967ED}"/>
               </a:ext>
             </a:extLst>
           </p:cNvPr>
@@ -17031,7 +16881,7 @@
           <p:cNvPr id="19" name="">
             <a:extLst xmlns:a="http://schemas.openxmlformats.org/drawingml/2006/main">
               <a:ext uri="{FF2B5EF4-FFF2-40B4-BE49-F238E27FC236}">
-                <a16:creationId xmlns:a16="http://schemas.microsoft.com/office/drawing/2014/main" id="{801A657A-C211-4A8C-89F1-048C45252F34}"/>
+                <a16:creationId xmlns:a16="http://schemas.microsoft.com/office/drawing/2014/main" id="{2C07D805-2A38-459E-A025-E628366DA8C7}"/>
               </a:ext>
             </a:extLst>
           </p:cNvPr>
@@ -19791,7 +19641,7 @@
           <p:cNvPr id="26" name="">
             <a:extLst xmlns:a="http://schemas.openxmlformats.org/drawingml/2006/main">
               <a:ext uri="{FF2B5EF4-FFF2-40B4-BE49-F238E27FC236}">
-                <a16:creationId xmlns:a16="http://schemas.microsoft.com/office/drawing/2014/main" id="{21FE302B-36B2-437A-9D7C-86FA793F0EC4}"/>
+                <a16:creationId xmlns:a16="http://schemas.microsoft.com/office/drawing/2014/main" id="{68B0273C-3D1C-413E-AE11-562ECC596D30}"/>
               </a:ext>
             </a:extLst>
           </p:cNvPr>
@@ -19823,7 +19673,7 @@
           <p:cNvPr id="25" name="">
             <a:extLst xmlns:a="http://schemas.openxmlformats.org/drawingml/2006/main">
               <a:ext uri="{FF2B5EF4-FFF2-40B4-BE49-F238E27FC236}">
-                <a16:creationId xmlns:a16="http://schemas.microsoft.com/office/drawing/2014/main" id="{698D47D0-D845-44B2-A278-C4B548EAC628}"/>
+                <a16:creationId xmlns:a16="http://schemas.microsoft.com/office/drawing/2014/main" id="{86C2F70E-957E-48BB-8CAA-8F9BF088CABF}"/>
               </a:ext>
             </a:extLst>
           </p:cNvPr>
@@ -19855,7 +19705,7 @@
           <p:cNvPr id="24" name="">
             <a:extLst xmlns:a="http://schemas.openxmlformats.org/drawingml/2006/main">
               <a:ext uri="{FF2B5EF4-FFF2-40B4-BE49-F238E27FC236}">
-                <a16:creationId xmlns:a16="http://schemas.microsoft.com/office/drawing/2014/main" id="{0EABF09E-BD04-47D1-B164-AEFFDDE0ED3A}"/>
+                <a16:creationId xmlns:a16="http://schemas.microsoft.com/office/drawing/2014/main" id="{74E8CF2C-2925-4A8A-B382-BCC3ACE41F1E}"/>
               </a:ext>
             </a:extLst>
           </p:cNvPr>
@@ -19887,7 +19737,7 @@
           <p:cNvPr id="23" name="">
             <a:extLst xmlns:a="http://schemas.openxmlformats.org/drawingml/2006/main">
               <a:ext uri="{FF2B5EF4-FFF2-40B4-BE49-F238E27FC236}">
-                <a16:creationId xmlns:a16="http://schemas.microsoft.com/office/drawing/2014/main" id="{4F8E4648-27AA-4D72-BDEC-CA4A99515D23}"/>
+                <a16:creationId xmlns:a16="http://schemas.microsoft.com/office/drawing/2014/main" id="{29F8B015-C511-44D3-9DAF-CCB0373350EE}"/>
               </a:ext>
             </a:extLst>
           </p:cNvPr>
@@ -19919,7 +19769,7 @@
           <p:cNvPr id="22" name="">
             <a:extLst xmlns:a="http://schemas.openxmlformats.org/drawingml/2006/main">
               <a:ext uri="{FF2B5EF4-FFF2-40B4-BE49-F238E27FC236}">
-                <a16:creationId xmlns:a16="http://schemas.microsoft.com/office/drawing/2014/main" id="{3DDFEFDA-D225-455C-979C-1D9A23453A37}"/>
+                <a16:creationId xmlns:a16="http://schemas.microsoft.com/office/drawing/2014/main" id="{B0C2270C-4939-453E-A907-D53B5AA45C08}"/>
               </a:ext>
             </a:extLst>
           </p:cNvPr>
@@ -24929,7 +24779,7 @@
           <p:cNvPr id="18" name="">
             <a:extLst xmlns:a="http://schemas.openxmlformats.org/drawingml/2006/main">
               <a:ext uri="{FF2B5EF4-FFF2-40B4-BE49-F238E27FC236}">
-                <a16:creationId xmlns:a16="http://schemas.microsoft.com/office/drawing/2014/main" id="{CFD58282-01AB-4B65-BA1E-7240375F267F}"/>
+                <a16:creationId xmlns:a16="http://schemas.microsoft.com/office/drawing/2014/main" id="{3EEEEB1C-84D3-4332-B53D-ABCEB4093AB6}"/>
               </a:ext>
             </a:extLst>
           </p:cNvPr>
@@ -24961,7 +24811,7 @@
           <p:cNvPr id="17" name="">
             <a:extLst xmlns:a="http://schemas.openxmlformats.org/drawingml/2006/main">
               <a:ext uri="{FF2B5EF4-FFF2-40B4-BE49-F238E27FC236}">
-                <a16:creationId xmlns:a16="http://schemas.microsoft.com/office/drawing/2014/main" id="{AA7CEC30-8CE1-4B29-8873-183D02DA02CF}"/>
+                <a16:creationId xmlns:a16="http://schemas.microsoft.com/office/drawing/2014/main" id="{FBDC73EB-1D1A-4185-A719-E8A3C3420FB6}"/>
               </a:ext>
             </a:extLst>
           </p:cNvPr>
@@ -24995,7 +24845,7 @@
           <p:cNvPr id="16" name="">
             <a:extLst xmlns:a="http://schemas.openxmlformats.org/drawingml/2006/main">
               <a:ext uri="{FF2B5EF4-FFF2-40B4-BE49-F238E27FC236}">
-                <a16:creationId xmlns:a16="http://schemas.microsoft.com/office/drawing/2014/main" id="{7AF3BA5E-9AE8-4122-BC2B-881250552013}"/>
+                <a16:creationId xmlns:a16="http://schemas.microsoft.com/office/drawing/2014/main" id="{A46CBCEB-D9DD-4A3F-AC8A-A922CD6F755E}"/>
               </a:ext>
             </a:extLst>
           </p:cNvPr>
@@ -27384,7 +27234,7 @@
           <p:cNvPr id="18" name="">
             <a:extLst xmlns:a="http://schemas.openxmlformats.org/drawingml/2006/main">
               <a:ext uri="{FF2B5EF4-FFF2-40B4-BE49-F238E27FC236}">
-                <a16:creationId xmlns:a16="http://schemas.microsoft.com/office/drawing/2014/main" id="{CA8DEC46-FE09-41E3-B7EE-6978109F75D0}"/>
+                <a16:creationId xmlns:a16="http://schemas.microsoft.com/office/drawing/2014/main" id="{3EF5805D-A4BA-47A5-B8A6-F52B3031054E}"/>
               </a:ext>
             </a:extLst>
           </p:cNvPr>
@@ -27416,7 +27266,7 @@
           <p:cNvPr id="17" name="">
             <a:extLst xmlns:a="http://schemas.openxmlformats.org/drawingml/2006/main">
               <a:ext uri="{FF2B5EF4-FFF2-40B4-BE49-F238E27FC236}">
-                <a16:creationId xmlns:a16="http://schemas.microsoft.com/office/drawing/2014/main" id="{4620B6AD-EEAA-42F3-BDB8-7DBCD71B2659}"/>
+                <a16:creationId xmlns:a16="http://schemas.microsoft.com/office/drawing/2014/main" id="{2554EA65-65B2-41EB-BB42-D5DE0B2A60E1}"/>
               </a:ext>
             </a:extLst>
           </p:cNvPr>
@@ -27448,7 +27298,7 @@
           <p:cNvPr id="16" name="">
             <a:extLst xmlns:a="http://schemas.openxmlformats.org/drawingml/2006/main">
               <a:ext uri="{FF2B5EF4-FFF2-40B4-BE49-F238E27FC236}">
-                <a16:creationId xmlns:a16="http://schemas.microsoft.com/office/drawing/2014/main" id="{1D72693C-2758-4F54-8293-20A3A3606B23}"/>
+                <a16:creationId xmlns:a16="http://schemas.microsoft.com/office/drawing/2014/main" id="{A5D62B7E-2C99-4670-B915-3895A1DF8EA7}"/>
               </a:ext>
             </a:extLst>
           </p:cNvPr>
@@ -29835,7 +29685,7 @@
           <p:cNvPr id="14" name="">
             <a:extLst xmlns:a="http://schemas.openxmlformats.org/drawingml/2006/main">
               <a:ext uri="{FF2B5EF4-FFF2-40B4-BE49-F238E27FC236}">
-                <a16:creationId xmlns:a16="http://schemas.microsoft.com/office/drawing/2014/main" id="{84DD4DB5-1237-4A4B-9B66-8C8EB79C5222}"/>
+                <a16:creationId xmlns:a16="http://schemas.microsoft.com/office/drawing/2014/main" id="{7C66F0FD-0C48-4BDA-BFD3-03FBF7247BF5}"/>
               </a:ext>
             </a:extLst>
           </p:cNvPr>
@@ -29867,7 +29717,7 @@
           <p:cNvPr id="13" name="">
             <a:extLst xmlns:a="http://schemas.openxmlformats.org/drawingml/2006/main">
               <a:ext uri="{FF2B5EF4-FFF2-40B4-BE49-F238E27FC236}">
-                <a16:creationId xmlns:a16="http://schemas.microsoft.com/office/drawing/2014/main" id="{62D781BE-8FA8-490F-8D1E-C6AC0DCFE2D0}"/>
+                <a16:creationId xmlns:a16="http://schemas.microsoft.com/office/drawing/2014/main" id="{E7AA5E4B-270F-4652-9D3E-C758BE088909}"/>
               </a:ext>
             </a:extLst>
           </p:cNvPr>
@@ -31881,7 +31731,7 @@
           <p:cNvPr id="14" name="">
             <a:extLst xmlns:a="http://schemas.openxmlformats.org/drawingml/2006/main">
               <a:ext uri="{FF2B5EF4-FFF2-40B4-BE49-F238E27FC236}">
-                <a16:creationId xmlns:a16="http://schemas.microsoft.com/office/drawing/2014/main" id="{144E6693-1BE5-4F1D-A3C5-CB179E8FBE3A}"/>
+                <a16:creationId xmlns:a16="http://schemas.microsoft.com/office/drawing/2014/main" id="{90D6277C-9354-4A69-92ED-98FA6478FD6F}"/>
               </a:ext>
             </a:extLst>
           </p:cNvPr>
@@ -31915,7 +31765,7 @@
           <p:cNvPr id="10" name="">
             <a:extLst xmlns:a="http://schemas.openxmlformats.org/drawingml/2006/main">
               <a:ext uri="{FF2B5EF4-FFF2-40B4-BE49-F238E27FC236}">
-                <a16:creationId xmlns:a16="http://schemas.microsoft.com/office/drawing/2014/main" id="{7A2AF9FE-8B16-4A83-9129-FFD153DFD946}"/>
+                <a16:creationId xmlns:a16="http://schemas.microsoft.com/office/drawing/2014/main" id="{0D563831-C3EF-4421-B133-A57086FEA759}"/>
               </a:ext>
             </a:extLst>
           </p:cNvPr>
@@ -34100,7 +33950,7 @@
           <p:cNvPr id="18" name="">
             <a:extLst xmlns:a="http://schemas.openxmlformats.org/drawingml/2006/main">
               <a:ext uri="{FF2B5EF4-FFF2-40B4-BE49-F238E27FC236}">
-                <a16:creationId xmlns:a16="http://schemas.microsoft.com/office/drawing/2014/main" id="{82EF5512-B139-43F0-836A-69160863751C}"/>
+                <a16:creationId xmlns:a16="http://schemas.microsoft.com/office/drawing/2014/main" id="{18C3A6FE-CF8F-4B69-B710-646579EB27E6}"/>
               </a:ext>
             </a:extLst>
           </p:cNvPr>
@@ -34132,7 +33982,7 @@
           <p:cNvPr id="17" name="">
             <a:extLst xmlns:a="http://schemas.openxmlformats.org/drawingml/2006/main">
               <a:ext uri="{FF2B5EF4-FFF2-40B4-BE49-F238E27FC236}">
-                <a16:creationId xmlns:a16="http://schemas.microsoft.com/office/drawing/2014/main" id="{6A1FEEFF-FAB0-4811-8A23-F9AB50D33B51}"/>
+                <a16:creationId xmlns:a16="http://schemas.microsoft.com/office/drawing/2014/main" id="{6D2AE24E-3A51-434C-85FA-0B70E36FC785}"/>
               </a:ext>
             </a:extLst>
           </p:cNvPr>
@@ -34164,7 +34014,7 @@
           <p:cNvPr id="16" name="">
             <a:extLst xmlns:a="http://schemas.openxmlformats.org/drawingml/2006/main">
               <a:ext uri="{FF2B5EF4-FFF2-40B4-BE49-F238E27FC236}">
-                <a16:creationId xmlns:a16="http://schemas.microsoft.com/office/drawing/2014/main" id="{2285E58C-ED50-4F16-BF9E-9C9BA6267A3C}"/>
+                <a16:creationId xmlns:a16="http://schemas.microsoft.com/office/drawing/2014/main" id="{EA029B4A-57EB-4D9D-A887-8ADDCFE9096B}"/>
               </a:ext>
             </a:extLst>
           </p:cNvPr>
@@ -36551,7 +36401,7 @@
           <p:cNvPr id="18" name="">
             <a:extLst xmlns:a="http://schemas.openxmlformats.org/drawingml/2006/main">
               <a:ext uri="{FF2B5EF4-FFF2-40B4-BE49-F238E27FC236}">
-                <a16:creationId xmlns:a16="http://schemas.microsoft.com/office/drawing/2014/main" id="{D58F95BE-5481-4DCD-86DB-75632796DCCB}"/>
+                <a16:creationId xmlns:a16="http://schemas.microsoft.com/office/drawing/2014/main" id="{15EFD23E-8B0E-4C6C-B5CA-DE960294C81E}"/>
               </a:ext>
             </a:extLst>
           </p:cNvPr>
@@ -36583,7 +36433,7 @@
           <p:cNvPr id="17" name="">
             <a:extLst xmlns:a="http://schemas.openxmlformats.org/drawingml/2006/main">
               <a:ext uri="{FF2B5EF4-FFF2-40B4-BE49-F238E27FC236}">
-                <a16:creationId xmlns:a16="http://schemas.microsoft.com/office/drawing/2014/main" id="{6E049983-9763-4DA8-A71C-FD6F579D1B5D}"/>
+                <a16:creationId xmlns:a16="http://schemas.microsoft.com/office/drawing/2014/main" id="{291FE03E-2638-4A00-8EB3-1BBE8C57F0C2}"/>
               </a:ext>
             </a:extLst>
           </p:cNvPr>
@@ -36615,7 +36465,7 @@
           <p:cNvPr id="16" name="">
             <a:extLst xmlns:a="http://schemas.openxmlformats.org/drawingml/2006/main">
               <a:ext uri="{FF2B5EF4-FFF2-40B4-BE49-F238E27FC236}">
-                <a16:creationId xmlns:a16="http://schemas.microsoft.com/office/drawing/2014/main" id="{9CEDE0C8-511B-4CEC-9C81-6D0B2D4F48B1}"/>
+                <a16:creationId xmlns:a16="http://schemas.microsoft.com/office/drawing/2014/main" id="{FA6AF4D6-1853-436B-86C1-8BE36584062D}"/>
               </a:ext>
             </a:extLst>
           </p:cNvPr>
@@ -39171,7 +39021,7 @@
           <p:cNvPr id="18" name="">
             <a:extLst xmlns:a="http://schemas.openxmlformats.org/drawingml/2006/main">
               <a:ext uri="{FF2B5EF4-FFF2-40B4-BE49-F238E27FC236}">
-                <a16:creationId xmlns:a16="http://schemas.microsoft.com/office/drawing/2014/main" id="{BD18EF46-0BC8-4E22-910D-1306DBFA086A}"/>
+                <a16:creationId xmlns:a16="http://schemas.microsoft.com/office/drawing/2014/main" id="{7E60DCDB-34FF-4C8A-8E4B-B1C4D9F00F0A}"/>
               </a:ext>
             </a:extLst>
           </p:cNvPr>
@@ -39205,7 +39055,7 @@
           <p:cNvPr id="14" name="">
             <a:extLst xmlns:a="http://schemas.openxmlformats.org/drawingml/2006/main">
               <a:ext uri="{FF2B5EF4-FFF2-40B4-BE49-F238E27FC236}">
-                <a16:creationId xmlns:a16="http://schemas.microsoft.com/office/drawing/2014/main" id="{8402A625-C297-41B0-BDF4-048C00747132}"/>
+                <a16:creationId xmlns:a16="http://schemas.microsoft.com/office/drawing/2014/main" id="{E64E8B5D-EA87-4CFF-9A33-F747D462B3CA}"/>
               </a:ext>
             </a:extLst>
           </p:cNvPr>
@@ -39239,7 +39089,7 @@
           <p:cNvPr id="10" name="">
             <a:extLst xmlns:a="http://schemas.openxmlformats.org/drawingml/2006/main">
               <a:ext uri="{FF2B5EF4-FFF2-40B4-BE49-F238E27FC236}">
-                <a16:creationId xmlns:a16="http://schemas.microsoft.com/office/drawing/2014/main" id="{6B0F4D93-9497-4893-8DDC-794C43183C85}"/>
+                <a16:creationId xmlns:a16="http://schemas.microsoft.com/office/drawing/2014/main" id="{0E1DCEAA-5CD0-4EFA-94BD-4CB6EA6C8BFD}"/>
               </a:ext>
             </a:extLst>
           </p:cNvPr>

</xml_diff>

<commit_message>
docs: remove presentation notes data
</commit_message>
<xml_diff>
--- a/StrongRoom-Presentation.pptx
+++ b/StrongRoom-Presentation.pptx
@@ -4,9 +4,6 @@
   <p:sldMasterIdLst>
     <p:sldMasterId xmlns:r="http://schemas.openxmlformats.org/officeDocument/2006/relationships" id="2147483648" r:id="R474872d57807432d"/>
   </p:sldMasterIdLst>
-  <p:notesMasterIdLst>
-    <p:notesMasterId xmlns:r="http://schemas.openxmlformats.org/officeDocument/2006/relationships" r:id="R04c5ffea6e504e81"/>
-  </p:notesMasterIdLst>
   <p:sldIdLst>
     <p:sldId xmlns:r="http://schemas.openxmlformats.org/officeDocument/2006/relationships" id="256" r:id="R8ee54361a7e849fc"/>
     <p:sldId xmlns:r="http://schemas.openxmlformats.org/officeDocument/2006/relationships" id="257" r:id="R541132f4fd214025"/>
@@ -25,1445 +22,7 @@
     <p:sldId xmlns:r="http://schemas.openxmlformats.org/officeDocument/2006/relationships" id="270" r:id="R980741ff0d4e4a55"/>
   </p:sldIdLst>
   <p:sldSz cx="12192000" cy="6858000"/>
-  <p:notesSz cx="6858000" cy="9144000"/>
 </p:presentation>
-</file>
-
-<file path=ppt/notesMasters/notesMaster1.xml><?xml version="1.0" encoding="utf-8"?>
-<p:notesMaster xmlns:p="http://schemas.openxmlformats.org/presentationml/2006/main">
-  <p:cSld>
-    <p:bg>
-      <p:bgRef idx="1001">
-        <a:schemeClr xmlns:a="http://schemas.openxmlformats.org/drawingml/2006/main" val="bg1"/>
-      </p:bgRef>
-    </p:bg>
-    <p:spTree>
-      <p:nvGrpSpPr>
-        <p:cNvPr id="1" name=""/>
-        <p:cNvGrpSpPr/>
-        <p:nvPr/>
-      </p:nvGrpSpPr>
-      <p:grpSpPr>
-        <a:xfrm xmlns:a="http://schemas.openxmlformats.org/drawingml/2006/main"/>
-      </p:grpSpPr>
-      <p:sp>
-        <p:nvSpPr>
-          <p:cNvPr id="2" name="Header Placeholder"/>
-          <p:cNvSpPr/>
-          <p:nvPr>
-            <p:ph type="hdr" sz="quarter"/>
-          </p:nvPr>
-        </p:nvSpPr>
-        <p:spPr>
-          <a:prstGeom xmlns:a="http://schemas.openxmlformats.org/drawingml/2006/main" prst="rect">
-            <a:avLst/>
-          </a:prstGeom>
-        </p:spPr>
-        <p:txBody>
-          <a:bodyPr xmlns:a="http://schemas.openxmlformats.org/drawingml/2006/main"/>
-          <a:lstStyle xmlns:a="http://schemas.openxmlformats.org/drawingml/2006/main"/>
-          <a:p xmlns:a="http://schemas.openxmlformats.org/drawingml/2006/main"/>
-        </p:txBody>
-      </p:sp>
-      <p:sp>
-        <p:nvSpPr>
-          <p:cNvPr id="3" name="Date Placeholder"/>
-          <p:cNvSpPr/>
-          <p:nvPr>
-            <p:ph type="dt" sz="quarter" idx="1"/>
-          </p:nvPr>
-        </p:nvSpPr>
-        <p:spPr>
-          <a:prstGeom xmlns:a="http://schemas.openxmlformats.org/drawingml/2006/main" prst="rect">
-            <a:avLst/>
-          </a:prstGeom>
-        </p:spPr>
-        <p:txBody>
-          <a:bodyPr xmlns:a="http://schemas.openxmlformats.org/drawingml/2006/main"/>
-          <a:lstStyle xmlns:a="http://schemas.openxmlformats.org/drawingml/2006/main"/>
-          <a:p xmlns:a="http://schemas.openxmlformats.org/drawingml/2006/main"/>
-        </p:txBody>
-      </p:sp>
-      <p:sp>
-        <p:nvSpPr>
-          <p:cNvPr id="4" name="Slide Image Placeholder"/>
-          <p:cNvSpPr/>
-          <p:nvPr>
-            <p:ph type="sldImg" idx="2"/>
-          </p:nvPr>
-        </p:nvSpPr>
-        <p:spPr>
-          <a:prstGeom xmlns:a="http://schemas.openxmlformats.org/drawingml/2006/main" prst="rect">
-            <a:avLst/>
-          </a:prstGeom>
-        </p:spPr>
-        <p:txBody>
-          <a:bodyPr xmlns:a="http://schemas.openxmlformats.org/drawingml/2006/main"/>
-          <a:lstStyle xmlns:a="http://schemas.openxmlformats.org/drawingml/2006/main"/>
-          <a:p xmlns:a="http://schemas.openxmlformats.org/drawingml/2006/main"/>
-        </p:txBody>
-      </p:sp>
-      <p:sp>
-        <p:nvSpPr>
-          <p:cNvPr id="5" name="Notes Placeholder"/>
-          <p:cNvSpPr/>
-          <p:nvPr>
-            <p:ph type="body" sz="quarter" idx="3"/>
-          </p:nvPr>
-        </p:nvSpPr>
-        <p:spPr>
-          <a:prstGeom xmlns:a="http://schemas.openxmlformats.org/drawingml/2006/main" prst="rect">
-            <a:avLst/>
-          </a:prstGeom>
-        </p:spPr>
-        <p:txBody>
-          <a:bodyPr xmlns:a="http://schemas.openxmlformats.org/drawingml/2006/main"/>
-          <a:lstStyle xmlns:a="http://schemas.openxmlformats.org/drawingml/2006/main"/>
-          <a:p xmlns:a="http://schemas.openxmlformats.org/drawingml/2006/main"/>
-        </p:txBody>
-      </p:sp>
-      <p:sp>
-        <p:nvSpPr>
-          <p:cNvPr id="6" name="Footer Placeholder"/>
-          <p:cNvSpPr/>
-          <p:nvPr>
-            <p:ph type="ftr" sz="quarter" idx="4"/>
-          </p:nvPr>
-        </p:nvSpPr>
-        <p:spPr>
-          <a:prstGeom xmlns:a="http://schemas.openxmlformats.org/drawingml/2006/main" prst="rect">
-            <a:avLst/>
-          </a:prstGeom>
-        </p:spPr>
-        <p:txBody>
-          <a:bodyPr xmlns:a="http://schemas.openxmlformats.org/drawingml/2006/main"/>
-          <a:lstStyle xmlns:a="http://schemas.openxmlformats.org/drawingml/2006/main"/>
-          <a:p xmlns:a="http://schemas.openxmlformats.org/drawingml/2006/main"/>
-        </p:txBody>
-      </p:sp>
-      <p:sp>
-        <p:nvSpPr>
-          <p:cNvPr id="7" name="Slide Number Placeholder"/>
-          <p:cNvSpPr/>
-          <p:nvPr>
-            <p:ph type="sldNum" sz="quarter" idx="5"/>
-          </p:nvPr>
-        </p:nvSpPr>
-        <p:spPr>
-          <a:prstGeom xmlns:a="http://schemas.openxmlformats.org/drawingml/2006/main" prst="rect">
-            <a:avLst/>
-          </a:prstGeom>
-        </p:spPr>
-        <p:txBody>
-          <a:bodyPr xmlns:a="http://schemas.openxmlformats.org/drawingml/2006/main"/>
-          <a:lstStyle xmlns:a="http://schemas.openxmlformats.org/drawingml/2006/main"/>
-          <a:p xmlns:a="http://schemas.openxmlformats.org/drawingml/2006/main"/>
-        </p:txBody>
-      </p:sp>
-    </p:spTree>
-  </p:cSld>
-  <p:clrMap bg1="lt1" tx1="dk1" bg2="lt2" tx2="dk2" accent1="accent1" accent2="accent2" accent3="accent3" accent4="accent4" accent5="accent5" accent6="accent6" hlink="hlink" folHlink="folHlink"/>
-  <p:notesStyle>
-    <a:lvl1pPr xmlns:a="http://schemas.openxmlformats.org/drawingml/2006/main" marL="0" algn="l" defTabSz="914400" rtl="0" eaLnBrk="1" latinLnBrk="0" hangingPunct="1">
-      <a:defRPr sz="1200" kern="1200"/>
-    </a:lvl1pPr>
-  </p:notesStyle>
-</p:notesMaster>
-</file>
-
-<file path=ppt/notesMasters/theme/theme3.xml><?xml version="1.0" encoding="utf-8"?>
-<a:theme xmlns:a="http://schemas.openxmlformats.org/drawingml/2006/main" name="ChatGPT">
-  <a:themeElements>
-    <a:clrScheme name="ChatGPT">
-      <a:dk1>
-        <a:srgbClr val="000000"/>
-      </a:dk1>
-      <a:lt1>
-        <a:srgbClr val="FFFFFF"/>
-      </a:lt1>
-      <a:dk2>
-        <a:srgbClr val="0E2841"/>
-      </a:dk2>
-      <a:lt2>
-        <a:srgbClr val="E8E8E8"/>
-      </a:lt2>
-      <a:accent1>
-        <a:srgbClr val="156082"/>
-      </a:accent1>
-      <a:accent2>
-        <a:srgbClr val="E97132"/>
-      </a:accent2>
-      <a:accent3>
-        <a:srgbClr val="196B24"/>
-      </a:accent3>
-      <a:accent4>
-        <a:srgbClr val="0F9ED5"/>
-      </a:accent4>
-      <a:accent5>
-        <a:srgbClr val="A02B93"/>
-      </a:accent5>
-      <a:accent6>
-        <a:srgbClr val="4EA72E"/>
-      </a:accent6>
-      <a:hlink>
-        <a:srgbClr val="467886"/>
-      </a:hlink>
-      <a:folHlink>
-        <a:srgbClr val="96607D"/>
-      </a:folHlink>
-    </a:clrScheme>
-    <a:fontScheme name="">
-      <a:majorFont>
-        <a:latin typeface="Aptos"/>
-        <a:ea typeface=""/>
-        <a:cs typeface=""/>
-      </a:majorFont>
-      <a:minorFont>
-        <a:latin typeface="Aptos"/>
-        <a:ea typeface=""/>
-        <a:cs typeface=""/>
-      </a:minorFont>
-    </a:fontScheme>
-    <a:fmtScheme name="ChatGPT">
-      <a:fillStyleLst>
-        <a:solidFill>
-          <a:schemeClr val="phClr"/>
-        </a:solidFill>
-        <a:gradFill>
-          <a:gsLst>
-            <a:gs pos="0">
-              <a:schemeClr val="phClr">
-                <a:tint val="67000"/>
-                <a:lumMod val="110000"/>
-                <a:satMod val="105000"/>
-              </a:schemeClr>
-            </a:gs>
-            <a:gs pos="50000">
-              <a:schemeClr val="phClr">
-                <a:tint val="73000"/>
-                <a:lumMod val="105000"/>
-                <a:satMod val="103000"/>
-              </a:schemeClr>
-            </a:gs>
-            <a:gs pos="100000">
-              <a:schemeClr val="phClr">
-                <a:tint val="81000"/>
-                <a:lumMod val="105000"/>
-                <a:satMod val="109000"/>
-              </a:schemeClr>
-            </a:gs>
-          </a:gsLst>
-          <a:lin ang="5400000" scaled="0"/>
-        </a:gradFill>
-        <a:gradFill>
-          <a:gsLst>
-            <a:gs pos="0">
-              <a:schemeClr val="phClr">
-                <a:tint val="94000"/>
-                <a:lumMod val="102000"/>
-                <a:satMod val="103000"/>
-              </a:schemeClr>
-            </a:gs>
-            <a:gs pos="50000">
-              <a:schemeClr val="phClr">
-                <a:shade val="100000"/>
-                <a:lumMod val="100000"/>
-                <a:satMod val="110000"/>
-              </a:schemeClr>
-            </a:gs>
-            <a:gs pos="100000">
-              <a:schemeClr val="phClr">
-                <a:shade val="78000"/>
-                <a:lumMod val="99000"/>
-                <a:satMod val="120000"/>
-              </a:schemeClr>
-            </a:gs>
-          </a:gsLst>
-          <a:lin ang="5400000" scaled="0"/>
-        </a:gradFill>
-      </a:fillStyleLst>
-      <a:lnStyleLst>
-        <a:ln w="12700">
-          <a:solidFill>
-            <a:schemeClr val="phClr"/>
-          </a:solidFill>
-          <a:prstDash val="solid"/>
-        </a:ln>
-        <a:ln w="19050">
-          <a:solidFill>
-            <a:schemeClr val="phClr"/>
-          </a:solidFill>
-          <a:prstDash val="solid"/>
-        </a:ln>
-        <a:ln w="25400">
-          <a:solidFill>
-            <a:schemeClr val="phClr"/>
-          </a:solidFill>
-          <a:prstDash val="solid"/>
-        </a:ln>
-      </a:lnStyleLst>
-      <a:effectStyleLst>
-        <a:effectStyle>
-          <a:effectLst/>
-        </a:effectStyle>
-        <a:effectStyle>
-          <a:effectLst/>
-        </a:effectStyle>
-        <a:effectStyle>
-          <a:effectLst>
-            <a:outerShdw blurRad="57150" dist="19050" dir="5400000">
-              <a:srgbClr val="000000">
-                <a:alpha val="16000"/>
-              </a:srgbClr>
-            </a:outerShdw>
-          </a:effectLst>
-        </a:effectStyle>
-        <a:effectStyle>
-          <a:effectLst>
-            <a:outerShdw blurRad="19050" dist="9525" dir="5400000">
-              <a:srgbClr val="000000">
-                <a:alpha val="6000"/>
-              </a:srgbClr>
-            </a:outerShdw>
-          </a:effectLst>
-        </a:effectStyle>
-        <a:effectStyle>
-          <a:effectLst>
-            <a:outerShdw blurRad="28575" dist="9525" dir="5400000">
-              <a:srgbClr val="000000">
-                <a:alpha val="8000"/>
-              </a:srgbClr>
-            </a:outerShdw>
-          </a:effectLst>
-        </a:effectStyle>
-        <a:effectStyle>
-          <a:effectLst>
-            <a:outerShdw blurRad="57150" dist="19050" dir="5400000">
-              <a:srgbClr val="000000">
-                <a:alpha val="10000"/>
-              </a:srgbClr>
-            </a:outerShdw>
-          </a:effectLst>
-        </a:effectStyle>
-        <a:effectStyle>
-          <a:effectLst>
-            <a:outerShdw blurRad="114300" dist="38100" dir="5400000">
-              <a:srgbClr val="000000">
-                <a:alpha val="12000"/>
-              </a:srgbClr>
-            </a:outerShdw>
-          </a:effectLst>
-        </a:effectStyle>
-        <a:effectStyle>
-          <a:effectLst>
-            <a:outerShdw blurRad="171450" dist="57150" dir="5400000">
-              <a:srgbClr val="000000">
-                <a:alpha val="16000"/>
-              </a:srgbClr>
-            </a:outerShdw>
-          </a:effectLst>
-        </a:effectStyle>
-        <a:effectStyle>
-          <a:effectLst>
-            <a:outerShdw blurRad="266700" dist="95250" dir="5400000">
-              <a:srgbClr val="000000">
-                <a:alpha val="24000"/>
-              </a:srgbClr>
-            </a:outerShdw>
-          </a:effectLst>
-        </a:effectStyle>
-      </a:effectStyleLst>
-      <a:bgFillStyleLst>
-        <a:solidFill>
-          <a:schemeClr val="phClr"/>
-        </a:solidFill>
-        <a:solidFill>
-          <a:schemeClr val="phClr">
-            <a:tint val="95000"/>
-            <a:satMod val="170000"/>
-          </a:schemeClr>
-        </a:solidFill>
-        <a:gradFill>
-          <a:gsLst>
-            <a:gs pos="0">
-              <a:schemeClr val="phClr">
-                <a:tint val="93000"/>
-                <a:shade val="98000"/>
-                <a:lumMod val="102000"/>
-                <a:satMod val="150000"/>
-              </a:schemeClr>
-            </a:gs>
-            <a:gs pos="50000">
-              <a:schemeClr val="phClr">
-                <a:tint val="98000"/>
-                <a:shade val="90000"/>
-                <a:lumMod val="103000"/>
-                <a:satMod val="130000"/>
-              </a:schemeClr>
-            </a:gs>
-            <a:gs pos="100000">
-              <a:schemeClr val="phClr">
-                <a:shade val="63000"/>
-                <a:satMod val="120000"/>
-              </a:schemeClr>
-            </a:gs>
-          </a:gsLst>
-          <a:lin ang="5400000" scaled="0"/>
-        </a:gradFill>
-      </a:bgFillStyleLst>
-    </a:fmtScheme>
-  </a:themeElements>
-</a:theme>
-</file>
-
-<file path=ppt/notesSlides/notesSlide1.xml><?xml version="1.0" encoding="utf-8"?>
-<p:notes xmlns:p="http://schemas.openxmlformats.org/presentationml/2006/main">
-  <p:cSld>
-    <p:spTree>
-      <p:nvGrpSpPr>
-        <p:cNvPr id="1" name=""/>
-        <p:cNvGrpSpPr/>
-        <p:nvPr/>
-      </p:nvGrpSpPr>
-      <p:grpSpPr>
-        <a:xfrm xmlns:a="http://schemas.openxmlformats.org/drawingml/2006/main"/>
-      </p:grpSpPr>
-      <p:sp>
-        <p:nvSpPr>
-          <p:cNvPr id="2" name="Slide Image Placeholder 1"/>
-          <p:cNvSpPr>
-            <a:spLocks xmlns:a="http://schemas.openxmlformats.org/drawingml/2006/main" noGrp="1"/>
-          </p:cNvSpPr>
-          <p:nvPr>
-            <p:ph type="sldImg" idx="0"/>
-          </p:nvPr>
-        </p:nvSpPr>
-        <p:spPr/>
-      </p:sp>
-      <p:sp>
-        <p:nvSpPr>
-          <p:cNvPr id="3" name="Notes Placeholder 2"/>
-          <p:cNvSpPr>
-            <a:spLocks xmlns:a="http://schemas.openxmlformats.org/drawingml/2006/main" noGrp="1"/>
-          </p:cNvSpPr>
-          <p:nvPr>
-            <p:ph type="body" idx="1"/>
-          </p:nvPr>
-        </p:nvSpPr>
-        <p:spPr/>
-        <p:txBody>
-          <a:bodyPr xmlns:a="http://schemas.openxmlformats.org/drawingml/2006/main"/>
-          <a:lstStyle xmlns:a="http://schemas.openxmlformats.org/drawingml/2006/main"/>
-          <a:p xmlns:a="http://schemas.openxmlformats.org/drawingml/2006/main">
-            <a:r>
-              <a:t/>
-            </a:r>
-          </a:p>
-        </p:txBody>
-      </p:sp>
-      <p:sp>
-        <p:nvSpPr>
-          <p:cNvPr id="4" name="Slide Number Placeholder 3"/>
-          <p:cNvSpPr>
-            <a:spLocks xmlns:a="http://schemas.openxmlformats.org/drawingml/2006/main" noGrp="1"/>
-          </p:cNvSpPr>
-          <p:nvPr>
-            <p:ph type="sldNum" idx="5"/>
-          </p:nvPr>
-        </p:nvSpPr>
-        <p:spPr/>
-        <p:txBody>
-          <a:bodyPr xmlns:a="http://schemas.openxmlformats.org/drawingml/2006/main"/>
-          <a:lstStyle xmlns:a="http://schemas.openxmlformats.org/drawingml/2006/main"/>
-          <a:p xmlns:a="http://schemas.openxmlformats.org/drawingml/2006/main"/>
-        </p:txBody>
-      </p:sp>
-    </p:spTree>
-  </p:cSld>
-  <p:clrMapOvr>
-    <a:masterClrMapping xmlns:a="http://schemas.openxmlformats.org/drawingml/2006/main"/>
-  </p:clrMapOvr>
-</p:notes>
-</file>
-
-<file path=ppt/notesSlides/notesSlide10.xml><?xml version="1.0" encoding="utf-8"?>
-<p:notes xmlns:p="http://schemas.openxmlformats.org/presentationml/2006/main">
-  <p:cSld>
-    <p:spTree>
-      <p:nvGrpSpPr>
-        <p:cNvPr id="1" name=""/>
-        <p:cNvGrpSpPr/>
-        <p:nvPr/>
-      </p:nvGrpSpPr>
-      <p:grpSpPr>
-        <a:xfrm xmlns:a="http://schemas.openxmlformats.org/drawingml/2006/main"/>
-      </p:grpSpPr>
-      <p:sp>
-        <p:nvSpPr>
-          <p:cNvPr id="2" name="Slide Image Placeholder 1"/>
-          <p:cNvSpPr>
-            <a:spLocks xmlns:a="http://schemas.openxmlformats.org/drawingml/2006/main" noGrp="1"/>
-          </p:cNvSpPr>
-          <p:nvPr>
-            <p:ph type="sldImg" idx="0"/>
-          </p:nvPr>
-        </p:nvSpPr>
-        <p:spPr/>
-      </p:sp>
-      <p:sp>
-        <p:nvSpPr>
-          <p:cNvPr id="3" name="Notes Placeholder 2"/>
-          <p:cNvSpPr>
-            <a:spLocks xmlns:a="http://schemas.openxmlformats.org/drawingml/2006/main" noGrp="1"/>
-          </p:cNvSpPr>
-          <p:nvPr>
-            <p:ph type="body" idx="1"/>
-          </p:nvPr>
-        </p:nvSpPr>
-        <p:spPr/>
-        <p:txBody>
-          <a:bodyPr xmlns:a="http://schemas.openxmlformats.org/drawingml/2006/main"/>
-          <a:lstStyle xmlns:a="http://schemas.openxmlformats.org/drawingml/2006/main"/>
-          <a:p xmlns:a="http://schemas.openxmlformats.org/drawingml/2006/main">
-            <a:r>
-              <a:t/>
-            </a:r>
-          </a:p>
-        </p:txBody>
-      </p:sp>
-      <p:sp>
-        <p:nvSpPr>
-          <p:cNvPr id="4" name="Slide Number Placeholder 3"/>
-          <p:cNvSpPr>
-            <a:spLocks xmlns:a="http://schemas.openxmlformats.org/drawingml/2006/main" noGrp="1"/>
-          </p:cNvSpPr>
-          <p:nvPr>
-            <p:ph type="sldNum" idx="5"/>
-          </p:nvPr>
-        </p:nvSpPr>
-        <p:spPr/>
-        <p:txBody>
-          <a:bodyPr xmlns:a="http://schemas.openxmlformats.org/drawingml/2006/main"/>
-          <a:lstStyle xmlns:a="http://schemas.openxmlformats.org/drawingml/2006/main"/>
-          <a:p xmlns:a="http://schemas.openxmlformats.org/drawingml/2006/main"/>
-        </p:txBody>
-      </p:sp>
-    </p:spTree>
-  </p:cSld>
-  <p:clrMapOvr>
-    <a:masterClrMapping xmlns:a="http://schemas.openxmlformats.org/drawingml/2006/main"/>
-  </p:clrMapOvr>
-</p:notes>
-</file>
-
-<file path=ppt/notesSlides/notesSlide11.xml><?xml version="1.0" encoding="utf-8"?>
-<p:notes xmlns:p="http://schemas.openxmlformats.org/presentationml/2006/main">
-  <p:cSld>
-    <p:spTree>
-      <p:nvGrpSpPr>
-        <p:cNvPr id="1" name=""/>
-        <p:cNvGrpSpPr/>
-        <p:nvPr/>
-      </p:nvGrpSpPr>
-      <p:grpSpPr>
-        <a:xfrm xmlns:a="http://schemas.openxmlformats.org/drawingml/2006/main"/>
-      </p:grpSpPr>
-      <p:sp>
-        <p:nvSpPr>
-          <p:cNvPr id="2" name="Slide Image Placeholder 1"/>
-          <p:cNvSpPr>
-            <a:spLocks xmlns:a="http://schemas.openxmlformats.org/drawingml/2006/main" noGrp="1"/>
-          </p:cNvSpPr>
-          <p:nvPr>
-            <p:ph type="sldImg" idx="0"/>
-          </p:nvPr>
-        </p:nvSpPr>
-        <p:spPr/>
-      </p:sp>
-      <p:sp>
-        <p:nvSpPr>
-          <p:cNvPr id="3" name="Notes Placeholder 2"/>
-          <p:cNvSpPr>
-            <a:spLocks xmlns:a="http://schemas.openxmlformats.org/drawingml/2006/main" noGrp="1"/>
-          </p:cNvSpPr>
-          <p:nvPr>
-            <p:ph type="body" idx="1"/>
-          </p:nvPr>
-        </p:nvSpPr>
-        <p:spPr/>
-        <p:txBody>
-          <a:bodyPr xmlns:a="http://schemas.openxmlformats.org/drawingml/2006/main"/>
-          <a:lstStyle xmlns:a="http://schemas.openxmlformats.org/drawingml/2006/main"/>
-          <a:p xmlns:a="http://schemas.openxmlformats.org/drawingml/2006/main">
-            <a:r>
-              <a:t/>
-            </a:r>
-          </a:p>
-        </p:txBody>
-      </p:sp>
-      <p:sp>
-        <p:nvSpPr>
-          <p:cNvPr id="4" name="Slide Number Placeholder 3"/>
-          <p:cNvSpPr>
-            <a:spLocks xmlns:a="http://schemas.openxmlformats.org/drawingml/2006/main" noGrp="1"/>
-          </p:cNvSpPr>
-          <p:nvPr>
-            <p:ph type="sldNum" idx="5"/>
-          </p:nvPr>
-        </p:nvSpPr>
-        <p:spPr/>
-        <p:txBody>
-          <a:bodyPr xmlns:a="http://schemas.openxmlformats.org/drawingml/2006/main"/>
-          <a:lstStyle xmlns:a="http://schemas.openxmlformats.org/drawingml/2006/main"/>
-          <a:p xmlns:a="http://schemas.openxmlformats.org/drawingml/2006/main"/>
-        </p:txBody>
-      </p:sp>
-    </p:spTree>
-  </p:cSld>
-  <p:clrMapOvr>
-    <a:masterClrMapping xmlns:a="http://schemas.openxmlformats.org/drawingml/2006/main"/>
-  </p:clrMapOvr>
-</p:notes>
-</file>
-
-<file path=ppt/notesSlides/notesSlide12.xml><?xml version="1.0" encoding="utf-8"?>
-<p:notes xmlns:p="http://schemas.openxmlformats.org/presentationml/2006/main">
-  <p:cSld>
-    <p:spTree>
-      <p:nvGrpSpPr>
-        <p:cNvPr id="1" name=""/>
-        <p:cNvGrpSpPr/>
-        <p:nvPr/>
-      </p:nvGrpSpPr>
-      <p:grpSpPr>
-        <a:xfrm xmlns:a="http://schemas.openxmlformats.org/drawingml/2006/main"/>
-      </p:grpSpPr>
-      <p:sp>
-        <p:nvSpPr>
-          <p:cNvPr id="2" name="Slide Image Placeholder 1"/>
-          <p:cNvSpPr>
-            <a:spLocks xmlns:a="http://schemas.openxmlformats.org/drawingml/2006/main" noGrp="1"/>
-          </p:cNvSpPr>
-          <p:nvPr>
-            <p:ph type="sldImg" idx="0"/>
-          </p:nvPr>
-        </p:nvSpPr>
-        <p:spPr/>
-      </p:sp>
-      <p:sp>
-        <p:nvSpPr>
-          <p:cNvPr id="3" name="Notes Placeholder 2"/>
-          <p:cNvSpPr>
-            <a:spLocks xmlns:a="http://schemas.openxmlformats.org/drawingml/2006/main" noGrp="1"/>
-          </p:cNvSpPr>
-          <p:nvPr>
-            <p:ph type="body" idx="1"/>
-          </p:nvPr>
-        </p:nvSpPr>
-        <p:spPr/>
-        <p:txBody>
-          <a:bodyPr xmlns:a="http://schemas.openxmlformats.org/drawingml/2006/main"/>
-          <a:lstStyle xmlns:a="http://schemas.openxmlformats.org/drawingml/2006/main"/>
-          <a:p xmlns:a="http://schemas.openxmlformats.org/drawingml/2006/main">
-            <a:r>
-              <a:t/>
-            </a:r>
-          </a:p>
-        </p:txBody>
-      </p:sp>
-      <p:sp>
-        <p:nvSpPr>
-          <p:cNvPr id="4" name="Slide Number Placeholder 3"/>
-          <p:cNvSpPr>
-            <a:spLocks xmlns:a="http://schemas.openxmlformats.org/drawingml/2006/main" noGrp="1"/>
-          </p:cNvSpPr>
-          <p:nvPr>
-            <p:ph type="sldNum" idx="5"/>
-          </p:nvPr>
-        </p:nvSpPr>
-        <p:spPr/>
-        <p:txBody>
-          <a:bodyPr xmlns:a="http://schemas.openxmlformats.org/drawingml/2006/main"/>
-          <a:lstStyle xmlns:a="http://schemas.openxmlformats.org/drawingml/2006/main"/>
-          <a:p xmlns:a="http://schemas.openxmlformats.org/drawingml/2006/main"/>
-        </p:txBody>
-      </p:sp>
-    </p:spTree>
-  </p:cSld>
-  <p:clrMapOvr>
-    <a:masterClrMapping xmlns:a="http://schemas.openxmlformats.org/drawingml/2006/main"/>
-  </p:clrMapOvr>
-</p:notes>
-</file>
-
-<file path=ppt/notesSlides/notesSlide13.xml><?xml version="1.0" encoding="utf-8"?>
-<p:notes xmlns:p="http://schemas.openxmlformats.org/presentationml/2006/main">
-  <p:cSld>
-    <p:spTree>
-      <p:nvGrpSpPr>
-        <p:cNvPr id="1" name=""/>
-        <p:cNvGrpSpPr/>
-        <p:nvPr/>
-      </p:nvGrpSpPr>
-      <p:grpSpPr>
-        <a:xfrm xmlns:a="http://schemas.openxmlformats.org/drawingml/2006/main"/>
-      </p:grpSpPr>
-      <p:sp>
-        <p:nvSpPr>
-          <p:cNvPr id="2" name="Slide Image Placeholder 1"/>
-          <p:cNvSpPr>
-            <a:spLocks xmlns:a="http://schemas.openxmlformats.org/drawingml/2006/main" noGrp="1"/>
-          </p:cNvSpPr>
-          <p:nvPr>
-            <p:ph type="sldImg" idx="0"/>
-          </p:nvPr>
-        </p:nvSpPr>
-        <p:spPr/>
-      </p:sp>
-      <p:sp>
-        <p:nvSpPr>
-          <p:cNvPr id="3" name="Notes Placeholder 2"/>
-          <p:cNvSpPr>
-            <a:spLocks xmlns:a="http://schemas.openxmlformats.org/drawingml/2006/main" noGrp="1"/>
-          </p:cNvSpPr>
-          <p:nvPr>
-            <p:ph type="body" idx="1"/>
-          </p:nvPr>
-        </p:nvSpPr>
-        <p:spPr/>
-        <p:txBody>
-          <a:bodyPr xmlns:a="http://schemas.openxmlformats.org/drawingml/2006/main"/>
-          <a:lstStyle xmlns:a="http://schemas.openxmlformats.org/drawingml/2006/main"/>
-          <a:p xmlns:a="http://schemas.openxmlformats.org/drawingml/2006/main">
-            <a:r>
-              <a:t/>
-            </a:r>
-          </a:p>
-        </p:txBody>
-      </p:sp>
-      <p:sp>
-        <p:nvSpPr>
-          <p:cNvPr id="4" name="Slide Number Placeholder 3"/>
-          <p:cNvSpPr>
-            <a:spLocks xmlns:a="http://schemas.openxmlformats.org/drawingml/2006/main" noGrp="1"/>
-          </p:cNvSpPr>
-          <p:nvPr>
-            <p:ph type="sldNum" idx="5"/>
-          </p:nvPr>
-        </p:nvSpPr>
-        <p:spPr/>
-        <p:txBody>
-          <a:bodyPr xmlns:a="http://schemas.openxmlformats.org/drawingml/2006/main"/>
-          <a:lstStyle xmlns:a="http://schemas.openxmlformats.org/drawingml/2006/main"/>
-          <a:p xmlns:a="http://schemas.openxmlformats.org/drawingml/2006/main"/>
-        </p:txBody>
-      </p:sp>
-    </p:spTree>
-  </p:cSld>
-  <p:clrMapOvr>
-    <a:masterClrMapping xmlns:a="http://schemas.openxmlformats.org/drawingml/2006/main"/>
-  </p:clrMapOvr>
-</p:notes>
-</file>
-
-<file path=ppt/notesSlides/notesSlide14.xml><?xml version="1.0" encoding="utf-8"?>
-<p:notes xmlns:p="http://schemas.openxmlformats.org/presentationml/2006/main">
-  <p:cSld>
-    <p:spTree>
-      <p:nvGrpSpPr>
-        <p:cNvPr id="1" name=""/>
-        <p:cNvGrpSpPr/>
-        <p:nvPr/>
-      </p:nvGrpSpPr>
-      <p:grpSpPr>
-        <a:xfrm xmlns:a="http://schemas.openxmlformats.org/drawingml/2006/main"/>
-      </p:grpSpPr>
-      <p:sp>
-        <p:nvSpPr>
-          <p:cNvPr id="2" name="Slide Image Placeholder 1"/>
-          <p:cNvSpPr>
-            <a:spLocks xmlns:a="http://schemas.openxmlformats.org/drawingml/2006/main" noGrp="1"/>
-          </p:cNvSpPr>
-          <p:nvPr>
-            <p:ph type="sldImg" idx="0"/>
-          </p:nvPr>
-        </p:nvSpPr>
-        <p:spPr/>
-      </p:sp>
-      <p:sp>
-        <p:nvSpPr>
-          <p:cNvPr id="3" name="Notes Placeholder 2"/>
-          <p:cNvSpPr>
-            <a:spLocks xmlns:a="http://schemas.openxmlformats.org/drawingml/2006/main" noGrp="1"/>
-          </p:cNvSpPr>
-          <p:nvPr>
-            <p:ph type="body" idx="1"/>
-          </p:nvPr>
-        </p:nvSpPr>
-        <p:spPr/>
-        <p:txBody>
-          <a:bodyPr xmlns:a="http://schemas.openxmlformats.org/drawingml/2006/main"/>
-          <a:lstStyle xmlns:a="http://schemas.openxmlformats.org/drawingml/2006/main"/>
-          <a:p xmlns:a="http://schemas.openxmlformats.org/drawingml/2006/main">
-            <a:r>
-              <a:t/>
-            </a:r>
-          </a:p>
-        </p:txBody>
-      </p:sp>
-      <p:sp>
-        <p:nvSpPr>
-          <p:cNvPr id="4" name="Slide Number Placeholder 3"/>
-          <p:cNvSpPr>
-            <a:spLocks xmlns:a="http://schemas.openxmlformats.org/drawingml/2006/main" noGrp="1"/>
-          </p:cNvSpPr>
-          <p:nvPr>
-            <p:ph type="sldNum" idx="5"/>
-          </p:nvPr>
-        </p:nvSpPr>
-        <p:spPr/>
-        <p:txBody>
-          <a:bodyPr xmlns:a="http://schemas.openxmlformats.org/drawingml/2006/main"/>
-          <a:lstStyle xmlns:a="http://schemas.openxmlformats.org/drawingml/2006/main"/>
-          <a:p xmlns:a="http://schemas.openxmlformats.org/drawingml/2006/main"/>
-        </p:txBody>
-      </p:sp>
-    </p:spTree>
-  </p:cSld>
-  <p:clrMapOvr>
-    <a:masterClrMapping xmlns:a="http://schemas.openxmlformats.org/drawingml/2006/main"/>
-  </p:clrMapOvr>
-</p:notes>
-</file>
-
-<file path=ppt/notesSlides/notesSlide15.xml><?xml version="1.0" encoding="utf-8"?>
-<p:notes xmlns:p="http://schemas.openxmlformats.org/presentationml/2006/main">
-  <p:cSld>
-    <p:spTree>
-      <p:nvGrpSpPr>
-        <p:cNvPr id="1" name=""/>
-        <p:cNvGrpSpPr/>
-        <p:nvPr/>
-      </p:nvGrpSpPr>
-      <p:grpSpPr>
-        <a:xfrm xmlns:a="http://schemas.openxmlformats.org/drawingml/2006/main"/>
-      </p:grpSpPr>
-      <p:sp>
-        <p:nvSpPr>
-          <p:cNvPr id="2" name="Slide Image Placeholder 1"/>
-          <p:cNvSpPr>
-            <a:spLocks xmlns:a="http://schemas.openxmlformats.org/drawingml/2006/main" noGrp="1"/>
-          </p:cNvSpPr>
-          <p:nvPr>
-            <p:ph type="sldImg" idx="0"/>
-          </p:nvPr>
-        </p:nvSpPr>
-        <p:spPr/>
-      </p:sp>
-      <p:sp>
-        <p:nvSpPr>
-          <p:cNvPr id="3" name="Notes Placeholder 2"/>
-          <p:cNvSpPr>
-            <a:spLocks xmlns:a="http://schemas.openxmlformats.org/drawingml/2006/main" noGrp="1"/>
-          </p:cNvSpPr>
-          <p:nvPr>
-            <p:ph type="body" idx="1"/>
-          </p:nvPr>
-        </p:nvSpPr>
-        <p:spPr/>
-        <p:txBody>
-          <a:bodyPr xmlns:a="http://schemas.openxmlformats.org/drawingml/2006/main"/>
-          <a:lstStyle xmlns:a="http://schemas.openxmlformats.org/drawingml/2006/main"/>
-          <a:p xmlns:a="http://schemas.openxmlformats.org/drawingml/2006/main">
-            <a:r>
-              <a:t/>
-            </a:r>
-          </a:p>
-        </p:txBody>
-      </p:sp>
-      <p:sp>
-        <p:nvSpPr>
-          <p:cNvPr id="4" name="Slide Number Placeholder 3"/>
-          <p:cNvSpPr>
-            <a:spLocks xmlns:a="http://schemas.openxmlformats.org/drawingml/2006/main" noGrp="1"/>
-          </p:cNvSpPr>
-          <p:nvPr>
-            <p:ph type="sldNum" idx="5"/>
-          </p:nvPr>
-        </p:nvSpPr>
-        <p:spPr/>
-        <p:txBody>
-          <a:bodyPr xmlns:a="http://schemas.openxmlformats.org/drawingml/2006/main"/>
-          <a:lstStyle xmlns:a="http://schemas.openxmlformats.org/drawingml/2006/main"/>
-          <a:p xmlns:a="http://schemas.openxmlformats.org/drawingml/2006/main"/>
-        </p:txBody>
-      </p:sp>
-    </p:spTree>
-  </p:cSld>
-  <p:clrMapOvr>
-    <a:masterClrMapping xmlns:a="http://schemas.openxmlformats.org/drawingml/2006/main"/>
-  </p:clrMapOvr>
-</p:notes>
-</file>
-
-<file path=ppt/notesSlides/notesSlide2.xml><?xml version="1.0" encoding="utf-8"?>
-<p:notes xmlns:p="http://schemas.openxmlformats.org/presentationml/2006/main">
-  <p:cSld>
-    <p:spTree>
-      <p:nvGrpSpPr>
-        <p:cNvPr id="1" name=""/>
-        <p:cNvGrpSpPr/>
-        <p:nvPr/>
-      </p:nvGrpSpPr>
-      <p:grpSpPr>
-        <a:xfrm xmlns:a="http://schemas.openxmlformats.org/drawingml/2006/main"/>
-      </p:grpSpPr>
-      <p:sp>
-        <p:nvSpPr>
-          <p:cNvPr id="2" name="Slide Image Placeholder 1"/>
-          <p:cNvSpPr>
-            <a:spLocks xmlns:a="http://schemas.openxmlformats.org/drawingml/2006/main" noGrp="1"/>
-          </p:cNvSpPr>
-          <p:nvPr>
-            <p:ph type="sldImg" idx="0"/>
-          </p:nvPr>
-        </p:nvSpPr>
-        <p:spPr/>
-      </p:sp>
-      <p:sp>
-        <p:nvSpPr>
-          <p:cNvPr id="3" name="Notes Placeholder 2"/>
-          <p:cNvSpPr>
-            <a:spLocks xmlns:a="http://schemas.openxmlformats.org/drawingml/2006/main" noGrp="1"/>
-          </p:cNvSpPr>
-          <p:nvPr>
-            <p:ph type="body" idx="1"/>
-          </p:nvPr>
-        </p:nvSpPr>
-        <p:spPr/>
-        <p:txBody>
-          <a:bodyPr xmlns:a="http://schemas.openxmlformats.org/drawingml/2006/main"/>
-          <a:lstStyle xmlns:a="http://schemas.openxmlformats.org/drawingml/2006/main"/>
-          <a:p xmlns:a="http://schemas.openxmlformats.org/drawingml/2006/main">
-            <a:r>
-              <a:t/>
-            </a:r>
-          </a:p>
-        </p:txBody>
-      </p:sp>
-      <p:sp>
-        <p:nvSpPr>
-          <p:cNvPr id="4" name="Slide Number Placeholder 3"/>
-          <p:cNvSpPr>
-            <a:spLocks xmlns:a="http://schemas.openxmlformats.org/drawingml/2006/main" noGrp="1"/>
-          </p:cNvSpPr>
-          <p:nvPr>
-            <p:ph type="sldNum" idx="5"/>
-          </p:nvPr>
-        </p:nvSpPr>
-        <p:spPr/>
-        <p:txBody>
-          <a:bodyPr xmlns:a="http://schemas.openxmlformats.org/drawingml/2006/main"/>
-          <a:lstStyle xmlns:a="http://schemas.openxmlformats.org/drawingml/2006/main"/>
-          <a:p xmlns:a="http://schemas.openxmlformats.org/drawingml/2006/main"/>
-        </p:txBody>
-      </p:sp>
-    </p:spTree>
-  </p:cSld>
-  <p:clrMapOvr>
-    <a:masterClrMapping xmlns:a="http://schemas.openxmlformats.org/drawingml/2006/main"/>
-  </p:clrMapOvr>
-</p:notes>
-</file>
-
-<file path=ppt/notesSlides/notesSlide3.xml><?xml version="1.0" encoding="utf-8"?>
-<p:notes xmlns:p="http://schemas.openxmlformats.org/presentationml/2006/main">
-  <p:cSld>
-    <p:spTree>
-      <p:nvGrpSpPr>
-        <p:cNvPr id="1" name=""/>
-        <p:cNvGrpSpPr/>
-        <p:nvPr/>
-      </p:nvGrpSpPr>
-      <p:grpSpPr>
-        <a:xfrm xmlns:a="http://schemas.openxmlformats.org/drawingml/2006/main"/>
-      </p:grpSpPr>
-      <p:sp>
-        <p:nvSpPr>
-          <p:cNvPr id="2" name="Slide Image Placeholder 1"/>
-          <p:cNvSpPr>
-            <a:spLocks xmlns:a="http://schemas.openxmlformats.org/drawingml/2006/main" noGrp="1"/>
-          </p:cNvSpPr>
-          <p:nvPr>
-            <p:ph type="sldImg" idx="0"/>
-          </p:nvPr>
-        </p:nvSpPr>
-        <p:spPr/>
-      </p:sp>
-      <p:sp>
-        <p:nvSpPr>
-          <p:cNvPr id="3" name="Notes Placeholder 2"/>
-          <p:cNvSpPr>
-            <a:spLocks xmlns:a="http://schemas.openxmlformats.org/drawingml/2006/main" noGrp="1"/>
-          </p:cNvSpPr>
-          <p:nvPr>
-            <p:ph type="body" idx="1"/>
-          </p:nvPr>
-        </p:nvSpPr>
-        <p:spPr/>
-        <p:txBody>
-          <a:bodyPr xmlns:a="http://schemas.openxmlformats.org/drawingml/2006/main"/>
-          <a:lstStyle xmlns:a="http://schemas.openxmlformats.org/drawingml/2006/main"/>
-          <a:p xmlns:a="http://schemas.openxmlformats.org/drawingml/2006/main">
-            <a:r>
-              <a:t/>
-            </a:r>
-          </a:p>
-        </p:txBody>
-      </p:sp>
-      <p:sp>
-        <p:nvSpPr>
-          <p:cNvPr id="4" name="Slide Number Placeholder 3"/>
-          <p:cNvSpPr>
-            <a:spLocks xmlns:a="http://schemas.openxmlformats.org/drawingml/2006/main" noGrp="1"/>
-          </p:cNvSpPr>
-          <p:nvPr>
-            <p:ph type="sldNum" idx="5"/>
-          </p:nvPr>
-        </p:nvSpPr>
-        <p:spPr/>
-        <p:txBody>
-          <a:bodyPr xmlns:a="http://schemas.openxmlformats.org/drawingml/2006/main"/>
-          <a:lstStyle xmlns:a="http://schemas.openxmlformats.org/drawingml/2006/main"/>
-          <a:p xmlns:a="http://schemas.openxmlformats.org/drawingml/2006/main"/>
-        </p:txBody>
-      </p:sp>
-    </p:spTree>
-  </p:cSld>
-  <p:clrMapOvr>
-    <a:masterClrMapping xmlns:a="http://schemas.openxmlformats.org/drawingml/2006/main"/>
-  </p:clrMapOvr>
-</p:notes>
-</file>
-
-<file path=ppt/notesSlides/notesSlide4.xml><?xml version="1.0" encoding="utf-8"?>
-<p:notes xmlns:p="http://schemas.openxmlformats.org/presentationml/2006/main">
-  <p:cSld>
-    <p:spTree>
-      <p:nvGrpSpPr>
-        <p:cNvPr id="1" name=""/>
-        <p:cNvGrpSpPr/>
-        <p:nvPr/>
-      </p:nvGrpSpPr>
-      <p:grpSpPr>
-        <a:xfrm xmlns:a="http://schemas.openxmlformats.org/drawingml/2006/main"/>
-      </p:grpSpPr>
-      <p:sp>
-        <p:nvSpPr>
-          <p:cNvPr id="2" name="Slide Image Placeholder 1"/>
-          <p:cNvSpPr>
-            <a:spLocks xmlns:a="http://schemas.openxmlformats.org/drawingml/2006/main" noGrp="1"/>
-          </p:cNvSpPr>
-          <p:nvPr>
-            <p:ph type="sldImg" idx="0"/>
-          </p:nvPr>
-        </p:nvSpPr>
-        <p:spPr/>
-      </p:sp>
-      <p:sp>
-        <p:nvSpPr>
-          <p:cNvPr id="3" name="Notes Placeholder 2"/>
-          <p:cNvSpPr>
-            <a:spLocks xmlns:a="http://schemas.openxmlformats.org/drawingml/2006/main" noGrp="1"/>
-          </p:cNvSpPr>
-          <p:nvPr>
-            <p:ph type="body" idx="1"/>
-          </p:nvPr>
-        </p:nvSpPr>
-        <p:spPr/>
-        <p:txBody>
-          <a:bodyPr xmlns:a="http://schemas.openxmlformats.org/drawingml/2006/main"/>
-          <a:lstStyle xmlns:a="http://schemas.openxmlformats.org/drawingml/2006/main"/>
-          <a:p xmlns:a="http://schemas.openxmlformats.org/drawingml/2006/main">
-            <a:r>
-              <a:t/>
-            </a:r>
-          </a:p>
-        </p:txBody>
-      </p:sp>
-      <p:sp>
-        <p:nvSpPr>
-          <p:cNvPr id="4" name="Slide Number Placeholder 3"/>
-          <p:cNvSpPr>
-            <a:spLocks xmlns:a="http://schemas.openxmlformats.org/drawingml/2006/main" noGrp="1"/>
-          </p:cNvSpPr>
-          <p:nvPr>
-            <p:ph type="sldNum" idx="5"/>
-          </p:nvPr>
-        </p:nvSpPr>
-        <p:spPr/>
-        <p:txBody>
-          <a:bodyPr xmlns:a="http://schemas.openxmlformats.org/drawingml/2006/main"/>
-          <a:lstStyle xmlns:a="http://schemas.openxmlformats.org/drawingml/2006/main"/>
-          <a:p xmlns:a="http://schemas.openxmlformats.org/drawingml/2006/main"/>
-        </p:txBody>
-      </p:sp>
-    </p:spTree>
-  </p:cSld>
-  <p:clrMapOvr>
-    <a:masterClrMapping xmlns:a="http://schemas.openxmlformats.org/drawingml/2006/main"/>
-  </p:clrMapOvr>
-</p:notes>
-</file>
-
-<file path=ppt/notesSlides/notesSlide5.xml><?xml version="1.0" encoding="utf-8"?>
-<p:notes xmlns:p="http://schemas.openxmlformats.org/presentationml/2006/main">
-  <p:cSld>
-    <p:spTree>
-      <p:nvGrpSpPr>
-        <p:cNvPr id="1" name=""/>
-        <p:cNvGrpSpPr/>
-        <p:nvPr/>
-      </p:nvGrpSpPr>
-      <p:grpSpPr>
-        <a:xfrm xmlns:a="http://schemas.openxmlformats.org/drawingml/2006/main"/>
-      </p:grpSpPr>
-      <p:sp>
-        <p:nvSpPr>
-          <p:cNvPr id="2" name="Slide Image Placeholder 1"/>
-          <p:cNvSpPr>
-            <a:spLocks xmlns:a="http://schemas.openxmlformats.org/drawingml/2006/main" noGrp="1"/>
-          </p:cNvSpPr>
-          <p:nvPr>
-            <p:ph type="sldImg" idx="0"/>
-          </p:nvPr>
-        </p:nvSpPr>
-        <p:spPr/>
-      </p:sp>
-      <p:sp>
-        <p:nvSpPr>
-          <p:cNvPr id="3" name="Notes Placeholder 2"/>
-          <p:cNvSpPr>
-            <a:spLocks xmlns:a="http://schemas.openxmlformats.org/drawingml/2006/main" noGrp="1"/>
-          </p:cNvSpPr>
-          <p:nvPr>
-            <p:ph type="body" idx="1"/>
-          </p:nvPr>
-        </p:nvSpPr>
-        <p:spPr/>
-        <p:txBody>
-          <a:bodyPr xmlns:a="http://schemas.openxmlformats.org/drawingml/2006/main"/>
-          <a:lstStyle xmlns:a="http://schemas.openxmlformats.org/drawingml/2006/main"/>
-          <a:p xmlns:a="http://schemas.openxmlformats.org/drawingml/2006/main">
-            <a:r>
-              <a:t/>
-            </a:r>
-          </a:p>
-        </p:txBody>
-      </p:sp>
-      <p:sp>
-        <p:nvSpPr>
-          <p:cNvPr id="4" name="Slide Number Placeholder 3"/>
-          <p:cNvSpPr>
-            <a:spLocks xmlns:a="http://schemas.openxmlformats.org/drawingml/2006/main" noGrp="1"/>
-          </p:cNvSpPr>
-          <p:nvPr>
-            <p:ph type="sldNum" idx="5"/>
-          </p:nvPr>
-        </p:nvSpPr>
-        <p:spPr/>
-        <p:txBody>
-          <a:bodyPr xmlns:a="http://schemas.openxmlformats.org/drawingml/2006/main"/>
-          <a:lstStyle xmlns:a="http://schemas.openxmlformats.org/drawingml/2006/main"/>
-          <a:p xmlns:a="http://schemas.openxmlformats.org/drawingml/2006/main"/>
-        </p:txBody>
-      </p:sp>
-    </p:spTree>
-  </p:cSld>
-  <p:clrMapOvr>
-    <a:masterClrMapping xmlns:a="http://schemas.openxmlformats.org/drawingml/2006/main"/>
-  </p:clrMapOvr>
-</p:notes>
-</file>
-
-<file path=ppt/notesSlides/notesSlide6.xml><?xml version="1.0" encoding="utf-8"?>
-<p:notes xmlns:p="http://schemas.openxmlformats.org/presentationml/2006/main">
-  <p:cSld>
-    <p:spTree>
-      <p:nvGrpSpPr>
-        <p:cNvPr id="1" name=""/>
-        <p:cNvGrpSpPr/>
-        <p:nvPr/>
-      </p:nvGrpSpPr>
-      <p:grpSpPr>
-        <a:xfrm xmlns:a="http://schemas.openxmlformats.org/drawingml/2006/main"/>
-      </p:grpSpPr>
-      <p:sp>
-        <p:nvSpPr>
-          <p:cNvPr id="2" name="Slide Image Placeholder 1"/>
-          <p:cNvSpPr>
-            <a:spLocks xmlns:a="http://schemas.openxmlformats.org/drawingml/2006/main" noGrp="1"/>
-          </p:cNvSpPr>
-          <p:nvPr>
-            <p:ph type="sldImg" idx="0"/>
-          </p:nvPr>
-        </p:nvSpPr>
-        <p:spPr/>
-      </p:sp>
-      <p:sp>
-        <p:nvSpPr>
-          <p:cNvPr id="3" name="Notes Placeholder 2"/>
-          <p:cNvSpPr>
-            <a:spLocks xmlns:a="http://schemas.openxmlformats.org/drawingml/2006/main" noGrp="1"/>
-          </p:cNvSpPr>
-          <p:nvPr>
-            <p:ph type="body" idx="1"/>
-          </p:nvPr>
-        </p:nvSpPr>
-        <p:spPr/>
-        <p:txBody>
-          <a:bodyPr xmlns:a="http://schemas.openxmlformats.org/drawingml/2006/main"/>
-          <a:lstStyle xmlns:a="http://schemas.openxmlformats.org/drawingml/2006/main"/>
-          <a:p xmlns:a="http://schemas.openxmlformats.org/drawingml/2006/main">
-            <a:r>
-              <a:t/>
-            </a:r>
-          </a:p>
-        </p:txBody>
-      </p:sp>
-      <p:sp>
-        <p:nvSpPr>
-          <p:cNvPr id="4" name="Slide Number Placeholder 3"/>
-          <p:cNvSpPr>
-            <a:spLocks xmlns:a="http://schemas.openxmlformats.org/drawingml/2006/main" noGrp="1"/>
-          </p:cNvSpPr>
-          <p:nvPr>
-            <p:ph type="sldNum" idx="5"/>
-          </p:nvPr>
-        </p:nvSpPr>
-        <p:spPr/>
-        <p:txBody>
-          <a:bodyPr xmlns:a="http://schemas.openxmlformats.org/drawingml/2006/main"/>
-          <a:lstStyle xmlns:a="http://schemas.openxmlformats.org/drawingml/2006/main"/>
-          <a:p xmlns:a="http://schemas.openxmlformats.org/drawingml/2006/main"/>
-        </p:txBody>
-      </p:sp>
-    </p:spTree>
-  </p:cSld>
-  <p:clrMapOvr>
-    <a:masterClrMapping xmlns:a="http://schemas.openxmlformats.org/drawingml/2006/main"/>
-  </p:clrMapOvr>
-</p:notes>
-</file>
-
-<file path=ppt/notesSlides/notesSlide7.xml><?xml version="1.0" encoding="utf-8"?>
-<p:notes xmlns:p="http://schemas.openxmlformats.org/presentationml/2006/main">
-  <p:cSld>
-    <p:spTree>
-      <p:nvGrpSpPr>
-        <p:cNvPr id="1" name=""/>
-        <p:cNvGrpSpPr/>
-        <p:nvPr/>
-      </p:nvGrpSpPr>
-      <p:grpSpPr>
-        <a:xfrm xmlns:a="http://schemas.openxmlformats.org/drawingml/2006/main"/>
-      </p:grpSpPr>
-      <p:sp>
-        <p:nvSpPr>
-          <p:cNvPr id="2" name="Slide Image Placeholder 1"/>
-          <p:cNvSpPr>
-            <a:spLocks xmlns:a="http://schemas.openxmlformats.org/drawingml/2006/main" noGrp="1"/>
-          </p:cNvSpPr>
-          <p:nvPr>
-            <p:ph type="sldImg" idx="0"/>
-          </p:nvPr>
-        </p:nvSpPr>
-        <p:spPr/>
-      </p:sp>
-      <p:sp>
-        <p:nvSpPr>
-          <p:cNvPr id="3" name="Notes Placeholder 2"/>
-          <p:cNvSpPr>
-            <a:spLocks xmlns:a="http://schemas.openxmlformats.org/drawingml/2006/main" noGrp="1"/>
-          </p:cNvSpPr>
-          <p:nvPr>
-            <p:ph type="body" idx="1"/>
-          </p:nvPr>
-        </p:nvSpPr>
-        <p:spPr/>
-        <p:txBody>
-          <a:bodyPr xmlns:a="http://schemas.openxmlformats.org/drawingml/2006/main"/>
-          <a:lstStyle xmlns:a="http://schemas.openxmlformats.org/drawingml/2006/main"/>
-          <a:p xmlns:a="http://schemas.openxmlformats.org/drawingml/2006/main">
-            <a:r>
-              <a:t/>
-            </a:r>
-          </a:p>
-        </p:txBody>
-      </p:sp>
-      <p:sp>
-        <p:nvSpPr>
-          <p:cNvPr id="4" name="Slide Number Placeholder 3"/>
-          <p:cNvSpPr>
-            <a:spLocks xmlns:a="http://schemas.openxmlformats.org/drawingml/2006/main" noGrp="1"/>
-          </p:cNvSpPr>
-          <p:nvPr>
-            <p:ph type="sldNum" idx="5"/>
-          </p:nvPr>
-        </p:nvSpPr>
-        <p:spPr/>
-        <p:txBody>
-          <a:bodyPr xmlns:a="http://schemas.openxmlformats.org/drawingml/2006/main"/>
-          <a:lstStyle xmlns:a="http://schemas.openxmlformats.org/drawingml/2006/main"/>
-          <a:p xmlns:a="http://schemas.openxmlformats.org/drawingml/2006/main"/>
-        </p:txBody>
-      </p:sp>
-    </p:spTree>
-  </p:cSld>
-  <p:clrMapOvr>
-    <a:masterClrMapping xmlns:a="http://schemas.openxmlformats.org/drawingml/2006/main"/>
-  </p:clrMapOvr>
-</p:notes>
-</file>
-
-<file path=ppt/notesSlides/notesSlide8.xml><?xml version="1.0" encoding="utf-8"?>
-<p:notes xmlns:p="http://schemas.openxmlformats.org/presentationml/2006/main">
-  <p:cSld>
-    <p:spTree>
-      <p:nvGrpSpPr>
-        <p:cNvPr id="1" name=""/>
-        <p:cNvGrpSpPr/>
-        <p:nvPr/>
-      </p:nvGrpSpPr>
-      <p:grpSpPr>
-        <a:xfrm xmlns:a="http://schemas.openxmlformats.org/drawingml/2006/main"/>
-      </p:grpSpPr>
-      <p:sp>
-        <p:nvSpPr>
-          <p:cNvPr id="2" name="Slide Image Placeholder 1"/>
-          <p:cNvSpPr>
-            <a:spLocks xmlns:a="http://schemas.openxmlformats.org/drawingml/2006/main" noGrp="1"/>
-          </p:cNvSpPr>
-          <p:nvPr>
-            <p:ph type="sldImg" idx="0"/>
-          </p:nvPr>
-        </p:nvSpPr>
-        <p:spPr/>
-      </p:sp>
-      <p:sp>
-        <p:nvSpPr>
-          <p:cNvPr id="3" name="Notes Placeholder 2"/>
-          <p:cNvSpPr>
-            <a:spLocks xmlns:a="http://schemas.openxmlformats.org/drawingml/2006/main" noGrp="1"/>
-          </p:cNvSpPr>
-          <p:nvPr>
-            <p:ph type="body" idx="1"/>
-          </p:nvPr>
-        </p:nvSpPr>
-        <p:spPr/>
-        <p:txBody>
-          <a:bodyPr xmlns:a="http://schemas.openxmlformats.org/drawingml/2006/main"/>
-          <a:lstStyle xmlns:a="http://schemas.openxmlformats.org/drawingml/2006/main"/>
-          <a:p xmlns:a="http://schemas.openxmlformats.org/drawingml/2006/main">
-            <a:r>
-              <a:t/>
-            </a:r>
-          </a:p>
-        </p:txBody>
-      </p:sp>
-      <p:sp>
-        <p:nvSpPr>
-          <p:cNvPr id="4" name="Slide Number Placeholder 3"/>
-          <p:cNvSpPr>
-            <a:spLocks xmlns:a="http://schemas.openxmlformats.org/drawingml/2006/main" noGrp="1"/>
-          </p:cNvSpPr>
-          <p:nvPr>
-            <p:ph type="sldNum" idx="5"/>
-          </p:nvPr>
-        </p:nvSpPr>
-        <p:spPr/>
-        <p:txBody>
-          <a:bodyPr xmlns:a="http://schemas.openxmlformats.org/drawingml/2006/main"/>
-          <a:lstStyle xmlns:a="http://schemas.openxmlformats.org/drawingml/2006/main"/>
-          <a:p xmlns:a="http://schemas.openxmlformats.org/drawingml/2006/main"/>
-        </p:txBody>
-      </p:sp>
-    </p:spTree>
-  </p:cSld>
-  <p:clrMapOvr>
-    <a:masterClrMapping xmlns:a="http://schemas.openxmlformats.org/drawingml/2006/main"/>
-  </p:clrMapOvr>
-</p:notes>
-</file>
-
-<file path=ppt/notesSlides/notesSlide9.xml><?xml version="1.0" encoding="utf-8"?>
-<p:notes xmlns:p="http://schemas.openxmlformats.org/presentationml/2006/main">
-  <p:cSld>
-    <p:spTree>
-      <p:nvGrpSpPr>
-        <p:cNvPr id="1" name=""/>
-        <p:cNvGrpSpPr/>
-        <p:nvPr/>
-      </p:nvGrpSpPr>
-      <p:grpSpPr>
-        <a:xfrm xmlns:a="http://schemas.openxmlformats.org/drawingml/2006/main"/>
-      </p:grpSpPr>
-      <p:sp>
-        <p:nvSpPr>
-          <p:cNvPr id="2" name="Slide Image Placeholder 1"/>
-          <p:cNvSpPr>
-            <a:spLocks xmlns:a="http://schemas.openxmlformats.org/drawingml/2006/main" noGrp="1"/>
-          </p:cNvSpPr>
-          <p:nvPr>
-            <p:ph type="sldImg" idx="0"/>
-          </p:nvPr>
-        </p:nvSpPr>
-        <p:spPr/>
-      </p:sp>
-      <p:sp>
-        <p:nvSpPr>
-          <p:cNvPr id="3" name="Notes Placeholder 2"/>
-          <p:cNvSpPr>
-            <a:spLocks xmlns:a="http://schemas.openxmlformats.org/drawingml/2006/main" noGrp="1"/>
-          </p:cNvSpPr>
-          <p:nvPr>
-            <p:ph type="body" idx="1"/>
-          </p:nvPr>
-        </p:nvSpPr>
-        <p:spPr/>
-        <p:txBody>
-          <a:bodyPr xmlns:a="http://schemas.openxmlformats.org/drawingml/2006/main"/>
-          <a:lstStyle xmlns:a="http://schemas.openxmlformats.org/drawingml/2006/main"/>
-          <a:p xmlns:a="http://schemas.openxmlformats.org/drawingml/2006/main">
-            <a:r>
-              <a:t/>
-            </a:r>
-          </a:p>
-        </p:txBody>
-      </p:sp>
-      <p:sp>
-        <p:nvSpPr>
-          <p:cNvPr id="4" name="Slide Number Placeholder 3"/>
-          <p:cNvSpPr>
-            <a:spLocks xmlns:a="http://schemas.openxmlformats.org/drawingml/2006/main" noGrp="1"/>
-          </p:cNvSpPr>
-          <p:nvPr>
-            <p:ph type="sldNum" idx="5"/>
-          </p:nvPr>
-        </p:nvSpPr>
-        <p:spPr/>
-        <p:txBody>
-          <a:bodyPr xmlns:a="http://schemas.openxmlformats.org/drawingml/2006/main"/>
-          <a:lstStyle xmlns:a="http://schemas.openxmlformats.org/drawingml/2006/main"/>
-          <a:p xmlns:a="http://schemas.openxmlformats.org/drawingml/2006/main"/>
-        </p:txBody>
-      </p:sp>
-    </p:spTree>
-  </p:cSld>
-  <p:clrMapOvr>
-    <a:masterClrMapping xmlns:a="http://schemas.openxmlformats.org/drawingml/2006/main"/>
-  </p:clrMapOvr>
-</p:notes>
 </file>
 
 <file path=ppt/slideLayouts/slideLayout1.xml><?xml version="1.0" encoding="utf-8"?>

</xml_diff>